<commit_message>
docs(ffw-sh5): 26.09.03 update — GR00T comparison, subtask results, language probe
Append the 26.09.03 section to the briefing (md + pptx, kept in sync):
checkpoint-10000 adoption, the GR00T action-representation finding
(relarm closes the +24% gap), and the subtask experiment verdict —
MSE-neutral in all three runs, and the language-sensitivity probe shows
GR00T weakly follows the sentence (+11% under wrong labels) while RLDX-1
ignores it entirely, because the subtask sentences are perfectly
correlated with the visual phase. remap_task_index.py builds the probe
dataset variants.

Co-Authored-By: Claude Fable 5 <noreply@anthropic.com>
Claude-Session: https://claude.ai/code/session_019bf8JsatqPk5i731jxBPea
</commit_message>
<xml_diff>
--- a/FFW-SH5-0826-finetune-briefing.pptx
+++ b/FFW-SH5-0826-finetune-briefing.pptx
@@ -22,6 +22,11 @@
     <p:sldId id="270" r:id="rId21"/>
     <p:sldId id="271" r:id="rId22"/>
     <p:sldId id="272" r:id="rId23"/>
+    <p:sldId id="273" r:id="rId24"/>
+    <p:sldId id="274" r:id="rId25"/>
+    <p:sldId id="275" r:id="rId26"/>
+    <p:sldId id="276" r:id="rId27"/>
+    <p:sldId id="277" r:id="rId28"/>
   </p:sldIdLst>
   <p:sldSz cx="12191695" cy="6858000" type="screen4x3"/>
   <p:notesSz cx="6858000" cy="9144000"/>
@@ -10021,7 +10026,7 @@
                 </a:solidFill>
                 <a:latin typeface="맑은 고딕"/>
               </a:rPr>
-              <a:t>1차 학습 결과 — checkpoint-10000이 최적</a:t>
+              <a:t>To-do</a:t>
             </a:r>
           </a:p>
           <a:p>
@@ -10037,7 +10042,7 @@
                 </a:solidFill>
                 <a:latin typeface="맑은 고딕"/>
               </a:rPr>
-              <a:t>30K 완주 후 held-out 채점</a:t>
+              <a:t>지금 / 학습 후 / 다음 데이터</a:t>
             </a:r>
           </a:p>
         </p:txBody>
@@ -10052,7 +10057,7 @@
         </p:nvGraphicFramePr>
         <p:xfrm>
           <a:off x="566928" y="1389888"/>
-          <a:ext cx="6583678" cy="1609344"/>
+          <a:ext cx="11057837" cy="3456432"/>
         </p:xfrm>
         <a:graphic>
           <a:graphicData uri="http://schemas.openxmlformats.org/drawingml/2006/table">
@@ -10061,31 +10066,29 @@
                 <a:tableStyleId>{5C22544A-7EE6-4342-B048-85BDC9FD1C3A}</a:tableStyleId>
               </a:tblPr>
               <a:tblGrid>
-                <a:gridCol w="1144987"/>
-                <a:gridCol w="1526650"/>
-                <a:gridCol w="1240403"/>
-                <a:gridCol w="1335819"/>
-                <a:gridCol w="1335819"/>
+                <a:gridCol w="1734562"/>
+                <a:gridCol w="4986868"/>
+                <a:gridCol w="4336407"/>
               </a:tblGrid>
-              <a:tr h="402336">
-                <a:tc>
-                  <a:txBody>
-                    <a:bodyPr wrap="square"/>
-                    <a:lstStyle/>
-                    <a:p>
-                      <a:pPr algn="l">
-                        <a:spcAft>
-                          <a:spcPts val="0"/>
-                        </a:spcAft>
-                      </a:pPr>
-                      <a:r>
-                        <a:rPr sz="1250" b="1">
+              <a:tr h="384048">
+                <a:tc>
+                  <a:txBody>
+                    <a:bodyPr wrap="square"/>
+                    <a:lstStyle/>
+                    <a:p>
+                      <a:pPr algn="l">
+                        <a:spcAft>
+                          <a:spcPts val="0"/>
+                        </a:spcAft>
+                      </a:pPr>
+                      <a:r>
+                        <a:rPr sz="1200" b="1">
                           <a:solidFill>
                             <a:srgbClr val="FFFFFF"/>
                           </a:solidFill>
                           <a:latin typeface="맑은 고딕"/>
                         </a:rPr>
-                        <a:t>step</a:t>
+                        <a:t>시점</a:t>
                       </a:r>
                     </a:p>
                   </a:txBody>
@@ -10106,13 +10109,13 @@
                         </a:spcAft>
                       </a:pPr>
                       <a:r>
-                        <a:rPr sz="1250" b="1">
+                        <a:rPr sz="1200" b="1">
                           <a:solidFill>
                             <a:srgbClr val="FFFFFF"/>
                           </a:solidFill>
                           <a:latin typeface="맑은 고딕"/>
                         </a:rPr>
-                        <a:t>held-out MSE</a:t>
+                        <a:t>할 일</a:t>
                       </a:r>
                     </a:p>
                   </a:txBody>
@@ -10133,13 +10136,13 @@
                         </a:spcAft>
                       </a:pPr>
                       <a:r>
-                        <a:rPr sz="1250" b="1">
+                        <a:rPr sz="1200" b="1">
                           <a:solidFill>
                             <a:srgbClr val="FFFFFF"/>
                           </a:solidFill>
                           <a:latin typeface="맑은 고딕"/>
                         </a:rPr>
-                        <a:t>MAE</a:t>
+                        <a:t>왜</a:t>
                       </a:r>
                     </a:p>
                   </a:txBody>
@@ -10149,80 +10152,26 @@
                     </a:solidFill>
                   </a:tcPr>
                 </a:tc>
-                <a:tc>
-                  <a:txBody>
-                    <a:bodyPr wrap="square"/>
-                    <a:lstStyle/>
-                    <a:p>
-                      <a:pPr algn="l">
-                        <a:spcAft>
-                          <a:spcPts val="0"/>
-                        </a:spcAft>
-                      </a:pPr>
-                      <a:r>
-                        <a:rPr sz="1250" b="1">
-                          <a:solidFill>
-                            <a:srgbClr val="FFFFFF"/>
-                          </a:solidFill>
-                          <a:latin typeface="맑은 고딕"/>
-                        </a:rPr>
-                        <a:t>최적 대비</a:t>
-                      </a:r>
-                    </a:p>
-                  </a:txBody>
-                  <a:tcPr marL="73152" marR="73152" marT="18288" marB="18288" anchor="ctr">
-                    <a:solidFill>
-                      <a:srgbClr val="1B3A5C"/>
-                    </a:solidFill>
-                  </a:tcPr>
-                </a:tc>
-                <a:tc>
-                  <a:txBody>
-                    <a:bodyPr wrap="square"/>
-                    <a:lstStyle/>
-                    <a:p>
-                      <a:pPr algn="l">
-                        <a:spcAft>
-                          <a:spcPts val="0"/>
-                        </a:spcAft>
-                      </a:pPr>
-                      <a:r>
-                        <a:rPr sz="1250" b="1">
-                          <a:solidFill>
-                            <a:srgbClr val="FFFFFF"/>
-                          </a:solidFill>
-                          <a:latin typeface="맑은 고딕"/>
-                        </a:rPr>
-                        <a:t>train loss</a:t>
-                      </a:r>
-                    </a:p>
-                  </a:txBody>
-                  <a:tcPr marL="73152" marR="73152" marT="18288" marB="18288" anchor="ctr">
-                    <a:solidFill>
-                      <a:srgbClr val="1B3A5C"/>
-                    </a:solidFill>
-                  </a:tcPr>
-                </a:tc>
               </a:tr>
-              <a:tr h="402336">
-                <a:tc>
-                  <a:txBody>
-                    <a:bodyPr wrap="square"/>
-                    <a:lstStyle/>
-                    <a:p>
-                      <a:pPr algn="l">
-                        <a:spcAft>
-                          <a:spcPts val="0"/>
-                        </a:spcAft>
-                      </a:pPr>
-                      <a:r>
-                        <a:rPr sz="1250" b="1">
-                          <a:solidFill>
-                            <a:srgbClr val="2E7D32"/>
-                          </a:solidFill>
-                          <a:latin typeface="맑은 고딕"/>
-                        </a:rPr>
-                        <a:t>10,000</a:t>
+              <a:tr h="384048">
+                <a:tc>
+                  <a:txBody>
+                    <a:bodyPr wrap="square"/>
+                    <a:lstStyle/>
+                    <a:p>
+                      <a:pPr algn="l">
+                        <a:spcAft>
+                          <a:spcPts val="0"/>
+                        </a:spcAft>
+                      </a:pPr>
+                      <a:r>
+                        <a:rPr sz="1200" b="1">
+                          <a:solidFill>
+                            <a:srgbClr val="20262E"/>
+                          </a:solidFill>
+                          <a:latin typeface="맑은 고딕"/>
+                        </a:rPr>
+                        <a:t>학습 도는 동안</a:t>
                       </a:r>
                     </a:p>
                   </a:txBody>
@@ -10243,13 +10192,13 @@
                         </a:spcAft>
                       </a:pPr>
                       <a:r>
-                        <a:rPr sz="1250" b="1">
-                          <a:solidFill>
-                            <a:srgbClr val="2E7D32"/>
-                          </a:solidFill>
-                          <a:latin typeface="맑은 고딕"/>
-                        </a:rPr>
-                        <a:t>0.02379</a:t>
+                        <a:rPr sz="1200" b="0">
+                          <a:solidFill>
+                            <a:srgbClr val="20262E"/>
+                          </a:solidFill>
+                          <a:latin typeface="맑은 고딕"/>
+                        </a:rPr>
+                        <a:t>배포 클라이언트의 26 → 57 관절 매핑 갱신</a:t>
                       </a:r>
                     </a:p>
                   </a:txBody>
@@ -10270,13 +10219,13 @@
                         </a:spcAft>
                       </a:pPr>
                       <a:r>
-                        <a:rPr sz="1250" b="1">
-                          <a:solidFill>
-                            <a:srgbClr val="20262E"/>
-                          </a:solidFill>
-                          <a:latin typeface="맑은 고딕"/>
-                        </a:rPr>
-                        <a:t>0.09208</a:t>
+                        <a:rPr sz="1200" b="0">
+                          <a:solidFill>
+                            <a:srgbClr val="20262E"/>
+                          </a:solidFill>
+                          <a:latin typeface="맑은 고딕"/>
+                        </a:rPr>
+                        <a:t>서버 출력 키가 바뀐다. 유일하게 한 번도 안 띄워본 경로</a:t>
                       </a:r>
                     </a:p>
                   </a:txBody>
@@ -10286,24 +10235,109 @@
                     </a:solidFill>
                   </a:tcPr>
                 </a:tc>
-                <a:tc>
-                  <a:txBody>
-                    <a:bodyPr wrap="square"/>
-                    <a:lstStyle/>
-                    <a:p>
-                      <a:pPr algn="l">
-                        <a:spcAft>
-                          <a:spcPts val="0"/>
-                        </a:spcAft>
-                      </a:pPr>
-                      <a:r>
-                        <a:rPr sz="1250" b="1">
-                          <a:solidFill>
-                            <a:srgbClr val="2E7D32"/>
-                          </a:solidFill>
-                          <a:latin typeface="맑은 고딕"/>
-                        </a:rPr>
-                        <a:t>— 최적</a:t>
+              </a:tr>
+              <a:tr h="384048">
+                <a:tc>
+                  <a:txBody>
+                    <a:bodyPr wrap="square"/>
+                    <a:lstStyle/>
+                    <a:p>
+                      <a:pPr algn="l">
+                        <a:spcAft>
+                          <a:spcPts val="0"/>
+                        </a:spcAft>
+                      </a:pPr>
+                      <a:r>
+                        <a:rPr sz="1200" b="0">
+                          <a:solidFill>
+                            <a:srgbClr val="20262E"/>
+                          </a:solidFill>
+                          <a:latin typeface="맑은 고딕"/>
+                        </a:rPr>
+                        <a:t/>
+                      </a:r>
+                    </a:p>
+                  </a:txBody>
+                  <a:tcPr marL="73152" marR="73152" marT="18288" marB="18288" anchor="ctr">
+                    <a:solidFill>
+                      <a:srgbClr val="F2F5F8"/>
+                    </a:solidFill>
+                  </a:tcPr>
+                </a:tc>
+                <a:tc>
+                  <a:txBody>
+                    <a:bodyPr wrap="square"/>
+                    <a:lstStyle/>
+                    <a:p>
+                      <a:pPr algn="l">
+                        <a:spcAft>
+                          <a:spcPts val="0"/>
+                        </a:spcAft>
+                      </a:pPr>
+                      <a:r>
+                        <a:rPr sz="1200" b="0">
+                          <a:solidFill>
+                            <a:srgbClr val="20262E"/>
+                          </a:solidFill>
+                          <a:latin typeface="맑은 고딕"/>
+                        </a:rPr>
+                        <a:t>로봇팀 확인: tactile 센서 1~3번이 왜 무응답인가</a:t>
+                      </a:r>
+                    </a:p>
+                  </a:txBody>
+                  <a:tcPr marL="73152" marR="73152" marT="18288" marB="18288" anchor="ctr">
+                    <a:solidFill>
+                      <a:srgbClr val="F2F5F8"/>
+                    </a:solidFill>
+                  </a:tcPr>
+                </a:tc>
+                <a:tc>
+                  <a:txBody>
+                    <a:bodyPr wrap="square"/>
+                    <a:lstStyle/>
+                    <a:p>
+                      <a:pPr algn="l">
+                        <a:spcAft>
+                          <a:spcPts val="0"/>
+                        </a:spcAft>
+                      </a:pPr>
+                      <a:r>
+                        <a:rPr sz="1200" b="0">
+                          <a:solidFill>
+                            <a:srgbClr val="20262E"/>
+                          </a:solidFill>
+                          <a:latin typeface="맑은 고딕"/>
+                        </a:rPr>
+                        <a:t>배선 문제면 다음 수집 전에 고쳐야 한다</a:t>
+                      </a:r>
+                    </a:p>
+                  </a:txBody>
+                  <a:tcPr marL="73152" marR="73152" marT="18288" marB="18288" anchor="ctr">
+                    <a:solidFill>
+                      <a:srgbClr val="F2F5F8"/>
+                    </a:solidFill>
+                  </a:tcPr>
+                </a:tc>
+              </a:tr>
+              <a:tr h="384048">
+                <a:tc>
+                  <a:txBody>
+                    <a:bodyPr wrap="square"/>
+                    <a:lstStyle/>
+                    <a:p>
+                      <a:pPr algn="l">
+                        <a:spcAft>
+                          <a:spcPts val="0"/>
+                        </a:spcAft>
+                      </a:pPr>
+                      <a:r>
+                        <a:rPr sz="1200" b="0">
+                          <a:solidFill>
+                            <a:srgbClr val="20262E"/>
+                          </a:solidFill>
+                          <a:latin typeface="맑은 고딕"/>
+                        </a:rPr>
+                        <a:t/>
                       </a:r>
                     </a:p>
                   </a:txBody>
@@ -10324,13 +10358,13 @@
                         </a:spcAft>
                       </a:pPr>
                       <a:r>
-                        <a:rPr sz="1250" b="0">
-                          <a:solidFill>
-                            <a:srgbClr val="20262E"/>
-                          </a:solidFill>
-                          <a:latin typeface="맑은 고딕"/>
-                        </a:rPr>
-                        <a:t>0.0129</a:t>
+                        <a:rPr sz="1200" b="0">
+                          <a:solidFill>
+                            <a:srgbClr val="20262E"/>
+                          </a:solidFill>
+                          <a:latin typeface="맑은 고딕"/>
+                        </a:rPr>
+                        <a:t>데이터팀 확인: 초기 송장 위치 분포 (front/top/hidden/side)</a:t>
                       </a:r>
                     </a:p>
                   </a:txBody>
@@ -10340,26 +10374,53 @@
                     </a:solidFill>
                   </a:tcPr>
                 </a:tc>
+                <a:tc>
+                  <a:txBody>
+                    <a:bodyPr wrap="square"/>
+                    <a:lstStyle/>
+                    <a:p>
+                      <a:pPr algn="l">
+                        <a:spcAft>
+                          <a:spcPts val="0"/>
+                        </a:spcAft>
+                      </a:pPr>
+                      <a:r>
+                        <a:rPr sz="1200" b="0">
+                          <a:solidFill>
+                            <a:srgbClr val="20262E"/>
+                          </a:solidFill>
+                          <a:latin typeface="맑은 고딕"/>
+                        </a:rPr>
+                        <a:t>분기 균형을 모르면 소수 분기가 학습되지 않는다</a:t>
+                      </a:r>
+                    </a:p>
+                  </a:txBody>
+                  <a:tcPr marL="73152" marR="73152" marT="18288" marB="18288" anchor="ctr">
+                    <a:solidFill>
+                      <a:srgbClr val="FFFFFF"/>
+                    </a:solidFill>
+                  </a:tcPr>
+                </a:tc>
               </a:tr>
-              <a:tr h="402336">
-                <a:tc>
-                  <a:txBody>
-                    <a:bodyPr wrap="square"/>
-                    <a:lstStyle/>
-                    <a:p>
-                      <a:pPr algn="l">
-                        <a:spcAft>
-                          <a:spcPts val="0"/>
-                        </a:spcAft>
-                      </a:pPr>
-                      <a:r>
-                        <a:rPr sz="1250" b="0">
-                          <a:solidFill>
-                            <a:srgbClr val="20262E"/>
-                          </a:solidFill>
-                          <a:latin typeface="맑은 고딕"/>
-                        </a:rPr>
-                        <a:t>20,000</a:t>
+              <a:tr h="384048">
+                <a:tc>
+                  <a:txBody>
+                    <a:bodyPr wrap="square"/>
+                    <a:lstStyle/>
+                    <a:p>
+                      <a:pPr algn="l">
+                        <a:spcAft>
+                          <a:spcPts val="0"/>
+                        </a:spcAft>
+                      </a:pPr>
+                      <a:r>
+                        <a:rPr sz="1200" b="1">
+                          <a:solidFill>
+                            <a:srgbClr val="20262E"/>
+                          </a:solidFill>
+                          <a:latin typeface="맑은 고딕"/>
+                        </a:rPr>
+                        <a:t>학습 직후</a:t>
                       </a:r>
                     </a:p>
                   </a:txBody>
@@ -10380,13 +10441,13 @@
                         </a:spcAft>
                       </a:pPr>
                       <a:r>
-                        <a:rPr sz="1250" b="0">
-                          <a:solidFill>
-                            <a:srgbClr val="20262E"/>
-                          </a:solidFill>
-                          <a:latin typeface="맑은 고딕"/>
-                        </a:rPr>
-                        <a:t>0.02653</a:t>
+                        <a:rPr sz="1200" b="0">
+                          <a:solidFill>
+                            <a:srgbClr val="20262E"/>
+                          </a:solidFill>
+                          <a:latin typeface="맑은 고딕"/>
+                        </a:rPr>
+                        <a:t>10K / 20K / 30K를 held-out으로 평가 → 최저 MSE 선택</a:t>
                       </a:r>
                     </a:p>
                   </a:txBody>
@@ -10407,13 +10468,13 @@
                         </a:spcAft>
                       </a:pPr>
                       <a:r>
-                        <a:rPr sz="1250" b="0">
-                          <a:solidFill>
-                            <a:srgbClr val="20262E"/>
-                          </a:solidFill>
-                          <a:latin typeface="맑은 고딕"/>
-                        </a:rPr>
-                        <a:t>0.09858</a:t>
+                        <a:rPr sz="1200" b="0">
+                          <a:solidFill>
+                            <a:srgbClr val="20262E"/>
+                          </a:solidFill>
+                          <a:latin typeface="맑은 고딕"/>
+                        </a:rPr>
+                        <a:t>validation이 없어 train loss만으로는 과적합을 못 본다</a:t>
                       </a:r>
                     </a:p>
                   </a:txBody>
@@ -10423,24 +10484,109 @@
                     </a:solidFill>
                   </a:tcPr>
                 </a:tc>
-                <a:tc>
-                  <a:txBody>
-                    <a:bodyPr wrap="square"/>
-                    <a:lstStyle/>
-                    <a:p>
-                      <a:pPr algn="l">
-                        <a:spcAft>
-                          <a:spcPts val="0"/>
-                        </a:spcAft>
-                      </a:pPr>
-                      <a:r>
-                        <a:rPr sz="1250" b="0">
-                          <a:solidFill>
-                            <a:srgbClr val="B4760A"/>
-                          </a:solidFill>
-                          <a:latin typeface="맑은 고딕"/>
-                        </a:rPr>
-                        <a:t>+11.6%</a:t>
+              </a:tr>
+              <a:tr h="384048">
+                <a:tc>
+                  <a:txBody>
+                    <a:bodyPr wrap="square"/>
+                    <a:lstStyle/>
+                    <a:p>
+                      <a:pPr algn="l">
+                        <a:spcAft>
+                          <a:spcPts val="0"/>
+                        </a:spcAft>
+                      </a:pPr>
+                      <a:r>
+                        <a:rPr sz="1200" b="0">
+                          <a:solidFill>
+                            <a:srgbClr val="20262E"/>
+                          </a:solidFill>
+                          <a:latin typeface="맑은 고딕"/>
+                        </a:rPr>
+                        <a:t/>
+                      </a:r>
+                    </a:p>
+                  </a:txBody>
+                  <a:tcPr marL="73152" marR="73152" marT="18288" marB="18288" anchor="ctr">
+                    <a:solidFill>
+                      <a:srgbClr val="FFFFFF"/>
+                    </a:solidFill>
+                  </a:tcPr>
+                </a:tc>
+                <a:tc>
+                  <a:txBody>
+                    <a:bodyPr wrap="square"/>
+                    <a:lstStyle/>
+                    <a:p>
+                      <a:pPr algn="l">
+                        <a:spcAft>
+                          <a:spcPts val="0"/>
+                        </a:spcAft>
+                      </a:pPr>
+                      <a:r>
+                        <a:rPr sz="1200" b="0">
+                          <a:solidFill>
+                            <a:srgbClr val="20262E"/>
+                          </a:solidFill>
+                          <a:latin typeface="맑은 고딕"/>
+                        </a:rPr>
+                        <a:t>실기 롤아웃으로 실패 모드 관찰</a:t>
+                      </a:r>
+                    </a:p>
+                  </a:txBody>
+                  <a:tcPr marL="73152" marR="73152" marT="18288" marB="18288" anchor="ctr">
+                    <a:solidFill>
+                      <a:srgbClr val="FFFFFF"/>
+                    </a:solidFill>
+                  </a:tcPr>
+                </a:tc>
+                <a:tc>
+                  <a:txBody>
+                    <a:bodyPr wrap="square"/>
+                    <a:lstStyle/>
+                    <a:p>
+                      <a:pPr algn="l">
+                        <a:spcAft>
+                          <a:spcPts val="0"/>
+                        </a:spcAft>
+                      </a:pPr>
+                      <a:r>
+                        <a:rPr sz="1200" b="0">
+                          <a:solidFill>
+                            <a:srgbClr val="20262E"/>
+                          </a:solidFill>
+                          <a:latin typeface="맑은 고딕"/>
+                        </a:rPr>
+                        <a:t>“전 구간 어설픔”인가 “전환 지점에서 멈춤”인가</a:t>
+                      </a:r>
+                    </a:p>
+                  </a:txBody>
+                  <a:tcPr marL="73152" marR="73152" marT="18288" marB="18288" anchor="ctr">
+                    <a:solidFill>
+                      <a:srgbClr val="FFFFFF"/>
+                    </a:solidFill>
+                  </a:tcPr>
+                </a:tc>
+              </a:tr>
+              <a:tr h="384048">
+                <a:tc>
+                  <a:txBody>
+                    <a:bodyPr wrap="square"/>
+                    <a:lstStyle/>
+                    <a:p>
+                      <a:pPr algn="l">
+                        <a:spcAft>
+                          <a:spcPts val="0"/>
+                        </a:spcAft>
+                      </a:pPr>
+                      <a:r>
+                        <a:rPr sz="1200" b="0">
+                          <a:solidFill>
+                            <a:srgbClr val="20262E"/>
+                          </a:solidFill>
+                          <a:latin typeface="맑은 고딕"/>
+                        </a:rPr>
+                        <a:t/>
                       </a:r>
                     </a:p>
                   </a:txBody>
@@ -10461,13 +10607,13 @@
                         </a:spcAft>
                       </a:pPr>
                       <a:r>
-                        <a:rPr sz="1250" b="0">
-                          <a:solidFill>
-                            <a:srgbClr val="20262E"/>
-                          </a:solidFill>
-                          <a:latin typeface="맑은 고딕"/>
-                        </a:rPr>
-                        <a:t>0.0034</a:t>
+                        <a:rPr sz="1200" b="0">
+                          <a:solidFill>
+                            <a:srgbClr val="20262E"/>
+                          </a:solidFill>
+                          <a:latin typeface="맑은 고딕"/>
+                        </a:rPr>
+                        <a:t>배포 시 40 중 20만 실행 (2.0초), 여유되면 RTC guided</a:t>
                       </a:r>
                     </a:p>
                   </a:txBody>
@@ -10477,26 +10623,53 @@
                     </a:solidFill>
                   </a:tcPr>
                 </a:tc>
+                <a:tc>
+                  <a:txBody>
+                    <a:bodyPr wrap="square"/>
+                    <a:lstStyle/>
+                    <a:p>
+                      <a:pPr algn="l">
+                        <a:spcAft>
+                          <a:spcPts val="0"/>
+                        </a:spcAft>
+                      </a:pPr>
+                      <a:r>
+                        <a:rPr sz="1200" b="0">
+                          <a:solidFill>
+                            <a:srgbClr val="20262E"/>
+                          </a:solidFill>
+                          <a:latin typeface="맑은 고딕"/>
+                        </a:rPr>
+                        <a:t>16개 전부 = 4초 open-loop는 컨베이어에서 길다</a:t>
+                      </a:r>
+                    </a:p>
+                  </a:txBody>
+                  <a:tcPr marL="73152" marR="73152" marT="18288" marB="18288" anchor="ctr">
+                    <a:solidFill>
+                      <a:srgbClr val="F2F5F8"/>
+                    </a:solidFill>
+                  </a:tcPr>
+                </a:tc>
               </a:tr>
-              <a:tr h="402336">
-                <a:tc>
-                  <a:txBody>
-                    <a:bodyPr wrap="square"/>
-                    <a:lstStyle/>
-                    <a:p>
-                      <a:pPr algn="l">
-                        <a:spcAft>
-                          <a:spcPts val="0"/>
-                        </a:spcAft>
-                      </a:pPr>
-                      <a:r>
-                        <a:rPr sz="1250" b="0">
-                          <a:solidFill>
-                            <a:srgbClr val="20262E"/>
-                          </a:solidFill>
-                          <a:latin typeface="맑은 고딕"/>
-                        </a:rPr>
-                        <a:t>30,000</a:t>
+              <a:tr h="384048">
+                <a:tc>
+                  <a:txBody>
+                    <a:bodyPr wrap="square"/>
+                    <a:lstStyle/>
+                    <a:p>
+                      <a:pPr algn="l">
+                        <a:spcAft>
+                          <a:spcPts val="0"/>
+                        </a:spcAft>
+                      </a:pPr>
+                      <a:r>
+                        <a:rPr sz="1200" b="1">
+                          <a:solidFill>
+                            <a:srgbClr val="20262E"/>
+                          </a:solidFill>
+                          <a:latin typeface="맑은 고딕"/>
+                        </a:rPr>
+                        <a:t>다음 데이터</a:t>
                       </a:r>
                     </a:p>
                   </a:txBody>
@@ -10517,13 +10690,13 @@
                         </a:spcAft>
                       </a:pPr>
                       <a:r>
-                        <a:rPr sz="1250" b="0">
-                          <a:solidFill>
-                            <a:srgbClr val="20262E"/>
-                          </a:solidFill>
-                          <a:latin typeface="맑은 고딕"/>
-                        </a:rPr>
-                        <a:t>0.02663</a:t>
+                        <a:rPr sz="1200" b="0">
+                          <a:solidFill>
+                            <a:srgbClr val="20262E"/>
+                          </a:solidFill>
+                          <a:latin typeface="맑은 고딕"/>
+                        </a:rPr>
+                        <a:t>부족한 분기를 골라 집중 수집 (논문 §4.3 adaptive collection)</a:t>
                       </a:r>
                     </a:p>
                   </a:txBody>
@@ -10544,13 +10717,13 @@
                         </a:spcAft>
                       </a:pPr>
                       <a:r>
-                        <a:rPr sz="1250" b="0">
-                          <a:solidFill>
-                            <a:srgbClr val="20262E"/>
-                          </a:solidFill>
-                          <a:latin typeface="맑은 고딕"/>
-                        </a:rPr>
-                        <a:t>0.09985</a:t>
+                        <a:rPr sz="1200" b="0">
+                          <a:solidFill>
+                            <a:srgbClr val="20262E"/>
+                          </a:solidFill>
+                          <a:latin typeface="맑은 고딕"/>
+                        </a:rPr>
+                        <a:t>무작정 늘리는 것보다 효율이 높다고 보고됨</a:t>
                       </a:r>
                     </a:p>
                   </a:txBody>
@@ -10560,57 +10733,86 @@
                     </a:solidFill>
                   </a:tcPr>
                 </a:tc>
-                <a:tc>
-                  <a:txBody>
-                    <a:bodyPr wrap="square"/>
-                    <a:lstStyle/>
-                    <a:p>
-                      <a:pPr algn="l">
-                        <a:spcAft>
-                          <a:spcPts val="0"/>
-                        </a:spcAft>
-                      </a:pPr>
-                      <a:r>
-                        <a:rPr sz="1250" b="0">
-                          <a:solidFill>
-                            <a:srgbClr val="B43A2E"/>
-                          </a:solidFill>
-                          <a:latin typeface="맑은 고딕"/>
-                        </a:rPr>
-                        <a:t>+11.9%</a:t>
-                      </a:r>
-                    </a:p>
-                  </a:txBody>
-                  <a:tcPr marL="73152" marR="73152" marT="18288" marB="18288" anchor="ctr">
-                    <a:solidFill>
-                      <a:srgbClr val="FFFFFF"/>
-                    </a:solidFill>
-                  </a:tcPr>
-                </a:tc>
-                <a:tc>
-                  <a:txBody>
-                    <a:bodyPr wrap="square"/>
-                    <a:lstStyle/>
-                    <a:p>
-                      <a:pPr algn="l">
-                        <a:spcAft>
-                          <a:spcPts val="0"/>
-                        </a:spcAft>
-                      </a:pPr>
-                      <a:r>
-                        <a:rPr sz="1250" b="1">
-                          <a:solidFill>
-                            <a:srgbClr val="20262E"/>
-                          </a:solidFill>
-                          <a:latin typeface="맑은 고딕"/>
-                        </a:rPr>
-                        <a:t>0.0031</a:t>
-                      </a:r>
-                    </a:p>
-                  </a:txBody>
-                  <a:tcPr marL="73152" marR="73152" marT="18288" marB="18288" anchor="ctr">
-                    <a:solidFill>
-                      <a:srgbClr val="FFFFFF"/>
+              </a:tr>
+              <a:tr h="384048">
+                <a:tc>
+                  <a:txBody>
+                    <a:bodyPr wrap="square"/>
+                    <a:lstStyle/>
+                    <a:p>
+                      <a:pPr algn="l">
+                        <a:spcAft>
+                          <a:spcPts val="0"/>
+                        </a:spcAft>
+                      </a:pPr>
+                      <a:r>
+                        <a:rPr sz="1200" b="0">
+                          <a:solidFill>
+                            <a:srgbClr val="20262E"/>
+                          </a:solidFill>
+                          <a:latin typeface="맑은 고딕"/>
+                        </a:rPr>
+                        <a:t/>
+                      </a:r>
+                    </a:p>
+                  </a:txBody>
+                  <a:tcPr marL="73152" marR="73152" marT="18288" marB="18288" anchor="ctr">
+                    <a:solidFill>
+                      <a:srgbClr val="F2F5F8"/>
+                    </a:solidFill>
+                  </a:tcPr>
+                </a:tc>
+                <a:tc>
+                  <a:txBody>
+                    <a:bodyPr wrap="square"/>
+                    <a:lstStyle/>
+                    <a:p>
+                      <a:pPr algn="l">
+                        <a:spcAft>
+                          <a:spcPts val="0"/>
+                        </a:spcAft>
+                      </a:pPr>
+                      <a:r>
+                        <a:rPr sz="1200" b="0">
+                          <a:solidFill>
+                            <a:srgbClr val="20262E"/>
+                          </a:solidFill>
+                          <a:latin typeface="맑은 고딕"/>
+                        </a:rPr>
+                        <a:t>필요해지면 subtask 도입 (B) — 코드는 이미 지원</a:t>
+                      </a:r>
+                    </a:p>
+                  </a:txBody>
+                  <a:tcPr marL="73152" marR="73152" marT="18288" marB="18288" anchor="ctr">
+                    <a:solidFill>
+                      <a:srgbClr val="F2F5F8"/>
+                    </a:solidFill>
+                  </a:tcPr>
+                </a:tc>
+                <a:tc>
+                  <a:txBody>
+                    <a:bodyPr wrap="square"/>
+                    <a:lstStyle/>
+                    <a:p>
+                      <a:pPr algn="l">
+                        <a:spcAft>
+                          <a:spcPts val="0"/>
+                        </a:spcAft>
+                      </a:pPr>
+                      <a:r>
+                        <a:rPr sz="1200" b="0">
+                          <a:solidFill>
+                            <a:srgbClr val="20262E"/>
+                          </a:solidFill>
+                          <a:latin typeface="맑은 고딕"/>
+                        </a:rPr>
+                        <a:t>1차 실패 모드가 “전환 지점”으로 나올 때만</a:t>
+                      </a:r>
+                    </a:p>
+                  </a:txBody>
+                  <a:tcPr marL="73152" marR="73152" marT="18288" marB="18288" anchor="ctr">
+                    <a:solidFill>
+                      <a:srgbClr val="F2F5F8"/>
                     </a:solidFill>
                   </a:tcPr>
                 </a:tc>
@@ -10621,509 +10823,14 @@
       </p:graphicFrame>
       <p:sp>
         <p:nvSpPr>
-          <p:cNvPr id="4" name="TextBox 3"/>
-          <p:cNvSpPr txBox="1"/>
-          <p:nvPr/>
-        </p:nvSpPr>
-        <p:spPr>
-          <a:xfrm>
-            <a:off x="7470648" y="1344168"/>
-            <a:ext cx="4709160" cy="2011680"/>
-          </a:xfrm>
-          <a:prstGeom prst="rect">
-            <a:avLst/>
-          </a:prstGeom>
-          <a:noFill/>
-        </p:spPr>
-        <p:txBody>
-          <a:bodyPr wrap="square">
-            <a:spAutoFit/>
-          </a:bodyPr>
-          <a:lstStyle/>
-          <a:p>
-            <a:pPr algn="l">
-              <a:spcAft>
-                <a:spcPts val="300"/>
-              </a:spcAft>
-            </a:pPr>
-            <a:r>
-              <a:rPr sz="1500" b="1">
-                <a:solidFill>
-                  <a:srgbClr val="1B3A5C"/>
-                </a:solidFill>
-                <a:latin typeface="맑은 고딕"/>
-              </a:rPr>
-              <a:t>train loss는 4배 좋아지는 동안</a:t>
-            </a:r>
-          </a:p>
-          <a:p>
-            <a:pPr algn="l">
-              <a:spcAft>
-                <a:spcPts val="900"/>
-              </a:spcAft>
-            </a:pPr>
-            <a:r>
-              <a:rPr sz="1500" b="1">
-                <a:solidFill>
-                  <a:srgbClr val="B43A2E"/>
-                </a:solidFill>
-                <a:latin typeface="맑은 고딕"/>
-              </a:rPr>
-              <a:t>held-out은 나빠졌다 — 과적합이다.</a:t>
-            </a:r>
-          </a:p>
-          <a:p>
-            <a:pPr algn="l">
-              <a:spcAft>
-                <a:spcPts val="900"/>
-              </a:spcAft>
-            </a:pPr>
-            <a:r>
-              <a:rPr sz="1500" b="1">
-                <a:solidFill>
-                  <a:srgbClr val="1F7A7A"/>
-                </a:solidFill>
-                <a:latin typeface="맑은 고딕"/>
-              </a:rPr>
-              <a:t>• </a:t>
-            </a:r>
-            <a:r>
-              <a:rPr sz="1300" b="0">
-                <a:solidFill>
-                  <a:srgbClr val="20262E"/>
-                </a:solidFill>
-                <a:latin typeface="맑은 고딕"/>
-              </a:rPr>
-              <a:t>0.0129 → 0.0031 (train)  vs  0.0238 → 0.0266 (held-out)</a:t>
-            </a:r>
-          </a:p>
-          <a:p>
-            <a:pPr algn="l">
-              <a:spcAft>
-                <a:spcPts val="900"/>
-              </a:spcAft>
-            </a:pPr>
-            <a:r>
-              <a:rPr sz="1500" b="1">
-                <a:solidFill>
-                  <a:srgbClr val="1F7A7A"/>
-                </a:solidFill>
-                <a:latin typeface="맑은 고딕"/>
-              </a:rPr>
-              <a:t>• </a:t>
-            </a:r>
-            <a:r>
-              <a:rPr sz="1300" b="0">
-                <a:solidFill>
-                  <a:srgbClr val="20262E"/>
-                </a:solidFill>
-                <a:latin typeface="맑은 고딕"/>
-              </a:rPr>
-              <a:t>그림: outputs/eval/holdout_curve.png</a:t>
-            </a:r>
-          </a:p>
-        </p:txBody>
-      </p:sp>
-      <p:sp>
-        <p:nvSpPr>
-          <p:cNvPr id="5" name="Rounded Rectangle 4"/>
-          <p:cNvSpPr/>
-          <p:nvPr/>
-        </p:nvSpPr>
-        <p:spPr>
-          <a:xfrm>
-            <a:off x="566928" y="3383280"/>
-            <a:ext cx="5577840" cy="1600200"/>
-          </a:xfrm>
-          <a:prstGeom prst="roundRect">
-            <a:avLst>
-              <a:gd name="adj" fmla="val 4000"/>
-            </a:avLst>
-          </a:prstGeom>
-          <a:solidFill>
-            <a:srgbClr val="F2F5F8"/>
-          </a:solidFill>
-          <a:ln w="19050">
-            <a:solidFill>
-              <a:srgbClr val="2E7D32"/>
-            </a:solidFill>
-          </a:ln>
-          <a:effectLst/>
-        </p:spPr>
-        <p:style>
-          <a:lnRef idx="1">
-            <a:schemeClr val="accent1"/>
-          </a:lnRef>
-          <a:fillRef idx="3">
-            <a:schemeClr val="accent1"/>
-          </a:fillRef>
-          <a:effectRef idx="2">
-            <a:schemeClr val="accent1"/>
-          </a:effectRef>
-          <a:fontRef idx="minor">
-            <a:schemeClr val="lt1"/>
-          </a:fontRef>
-        </p:style>
-        <p:txBody>
-          <a:bodyPr rtlCol="0" anchor="ctr"/>
-          <a:lstStyle/>
-          <a:p>
-            <a:pPr algn="ctr"/>
-          </a:p>
-        </p:txBody>
-      </p:sp>
-      <p:sp>
-        <p:nvSpPr>
-          <p:cNvPr id="6" name="Rectangle 5"/>
-          <p:cNvSpPr/>
-          <p:nvPr/>
-        </p:nvSpPr>
-        <p:spPr>
-          <a:xfrm>
-            <a:off x="566928" y="3383280"/>
-            <a:ext cx="64008" cy="1600200"/>
-          </a:xfrm>
-          <a:prstGeom prst="rect">
-            <a:avLst/>
-          </a:prstGeom>
-          <a:solidFill>
-            <a:srgbClr val="2E7D32"/>
-          </a:solidFill>
-          <a:ln>
-            <a:noFill/>
-          </a:ln>
-          <a:effectLst/>
-        </p:spPr>
-        <p:style>
-          <a:lnRef idx="1">
-            <a:schemeClr val="accent1"/>
-          </a:lnRef>
-          <a:fillRef idx="3">
-            <a:schemeClr val="accent1"/>
-          </a:fillRef>
-          <a:effectRef idx="2">
-            <a:schemeClr val="accent1"/>
-          </a:effectRef>
-          <a:fontRef idx="minor">
-            <a:schemeClr val="lt1"/>
-          </a:fontRef>
-        </p:style>
-        <p:txBody>
-          <a:bodyPr rtlCol="0" anchor="ctr"/>
-          <a:lstStyle/>
-          <a:p>
-            <a:pPr algn="ctr"/>
-          </a:p>
-        </p:txBody>
-      </p:sp>
-      <p:sp>
-        <p:nvSpPr>
-          <p:cNvPr id="7" name="TextBox 6"/>
-          <p:cNvSpPr txBox="1"/>
-          <p:nvPr/>
-        </p:nvSpPr>
-        <p:spPr>
-          <a:xfrm>
-            <a:off x="768096" y="3474720"/>
-            <a:ext cx="5212080" cy="1417320"/>
-          </a:xfrm>
-          <a:prstGeom prst="rect">
-            <a:avLst/>
-          </a:prstGeom>
-          <a:noFill/>
-        </p:spPr>
-        <p:txBody>
-          <a:bodyPr wrap="square">
-            <a:spAutoFit/>
-          </a:bodyPr>
-          <a:lstStyle/>
-          <a:p>
-            <a:pPr algn="l">
-              <a:spcAft>
-                <a:spcPts val="400"/>
-              </a:spcAft>
-            </a:pPr>
-            <a:r>
-              <a:rPr sz="1400" b="1">
-                <a:solidFill>
-                  <a:srgbClr val="2E7D32"/>
-                </a:solidFill>
-                <a:latin typeface="맑은 고딕"/>
-              </a:rPr>
-              <a:t>±15% 변동을 어떻게 넘어섰나</a:t>
-            </a:r>
-          </a:p>
-          <a:p>
-            <a:pPr algn="l">
-              <a:spcAft>
-                <a:spcPts val="300"/>
-              </a:spcAft>
-            </a:pPr>
-            <a:r>
-              <a:rPr sz="1250" b="0">
-                <a:solidFill>
-                  <a:srgbClr val="20262E"/>
-                </a:solidFill>
-                <a:latin typeface="맑은 고딕"/>
-              </a:rPr>
-              <a:t>같은 체크포인트도 실행마다 MSE가 ±15% 흔들린다(부록 A.4).</a:t>
-            </a:r>
-          </a:p>
-          <a:p>
-            <a:pPr algn="l">
-              <a:spcAft>
-                <a:spcPts val="300"/>
-              </a:spcAft>
-            </a:pPr>
-            <a:r>
-              <a:rPr sz="1250" b="0">
-                <a:solidFill>
-                  <a:srgbClr val="20262E"/>
-                </a:solidFill>
-                <a:latin typeface="맑은 고딕"/>
-              </a:rPr>
-              <a:t>평균 차이 11.6%는 그 폭 안이라 그것만으로는 약하다.</a:t>
-            </a:r>
-          </a:p>
-          <a:p>
-            <a:pPr algn="l">
-              <a:spcAft>
-                <a:spcPts val="300"/>
-              </a:spcAft>
-            </a:pPr>
-            <a:r>
-              <a:rPr sz="1250" b="0">
-                <a:solidFill>
-                  <a:srgbClr val="20262E"/>
-                </a:solidFill>
-                <a:latin typeface="맑은 고딕"/>
-              </a:rPr>
-              <a:t>→ 9개 에피소드를 짝지어 보니 step 10,000이 9/9 전부에서 이긴다.</a:t>
-            </a:r>
-          </a:p>
-          <a:p>
-            <a:pPr algn="l">
-              <a:spcAft>
-                <a:spcPts val="300"/>
-              </a:spcAft>
-            </a:pPr>
-            <a:r>
-              <a:rPr sz="1250" b="0">
-                <a:solidFill>
-                  <a:srgbClr val="20262E"/>
-                </a:solidFill>
-                <a:latin typeface="맑은 고딕"/>
-              </a:rPr>
-              <a:t>   노이즈는 에피소드마다 독립이므로 우연이 아니다.</a:t>
-            </a:r>
-          </a:p>
-        </p:txBody>
-      </p:sp>
-      <p:sp>
-        <p:nvSpPr>
-          <p:cNvPr id="8" name="Rounded Rectangle 7"/>
-          <p:cNvSpPr/>
-          <p:nvPr/>
-        </p:nvSpPr>
-        <p:spPr>
-          <a:xfrm>
-            <a:off x="6419088" y="3383280"/>
-            <a:ext cx="5184648" cy="1600200"/>
-          </a:xfrm>
-          <a:prstGeom prst="roundRect">
-            <a:avLst>
-              <a:gd name="adj" fmla="val 4000"/>
-            </a:avLst>
-          </a:prstGeom>
-          <a:solidFill>
-            <a:srgbClr val="F2F5F8"/>
-          </a:solidFill>
-          <a:ln w="19050">
-            <a:solidFill>
-              <a:srgbClr val="B4760A"/>
-            </a:solidFill>
-          </a:ln>
-          <a:effectLst/>
-        </p:spPr>
-        <p:style>
-          <a:lnRef idx="1">
-            <a:schemeClr val="accent1"/>
-          </a:lnRef>
-          <a:fillRef idx="3">
-            <a:schemeClr val="accent1"/>
-          </a:fillRef>
-          <a:effectRef idx="2">
-            <a:schemeClr val="accent1"/>
-          </a:effectRef>
-          <a:fontRef idx="minor">
-            <a:schemeClr val="lt1"/>
-          </a:fontRef>
-        </p:style>
-        <p:txBody>
-          <a:bodyPr rtlCol="0" anchor="ctr"/>
-          <a:lstStyle/>
-          <a:p>
-            <a:pPr algn="ctr"/>
-          </a:p>
-        </p:txBody>
-      </p:sp>
-      <p:sp>
-        <p:nvSpPr>
-          <p:cNvPr id="9" name="Rectangle 8"/>
-          <p:cNvSpPr/>
-          <p:nvPr/>
-        </p:nvSpPr>
-        <p:spPr>
-          <a:xfrm>
-            <a:off x="6419088" y="3383280"/>
-            <a:ext cx="64008" cy="1600200"/>
-          </a:xfrm>
-          <a:prstGeom prst="rect">
-            <a:avLst/>
-          </a:prstGeom>
-          <a:solidFill>
-            <a:srgbClr val="B4760A"/>
-          </a:solidFill>
-          <a:ln>
-            <a:noFill/>
-          </a:ln>
-          <a:effectLst/>
-        </p:spPr>
-        <p:style>
-          <a:lnRef idx="1">
-            <a:schemeClr val="accent1"/>
-          </a:lnRef>
-          <a:fillRef idx="3">
-            <a:schemeClr val="accent1"/>
-          </a:fillRef>
-          <a:effectRef idx="2">
-            <a:schemeClr val="accent1"/>
-          </a:effectRef>
-          <a:fontRef idx="minor">
-            <a:schemeClr val="lt1"/>
-          </a:fontRef>
-        </p:style>
-        <p:txBody>
-          <a:bodyPr rtlCol="0" anchor="ctr"/>
-          <a:lstStyle/>
-          <a:p>
-            <a:pPr algn="ctr"/>
-          </a:p>
-        </p:txBody>
-      </p:sp>
-      <p:sp>
-        <p:nvSpPr>
-          <p:cNvPr id="10" name="TextBox 9"/>
-          <p:cNvSpPr txBox="1"/>
-          <p:nvPr/>
-        </p:nvSpPr>
-        <p:spPr>
-          <a:xfrm>
-            <a:off x="6620256" y="3474720"/>
-            <a:ext cx="4818888" cy="1417320"/>
-          </a:xfrm>
-          <a:prstGeom prst="rect">
-            <a:avLst/>
-          </a:prstGeom>
-          <a:noFill/>
-        </p:spPr>
-        <p:txBody>
-          <a:bodyPr wrap="square">
-            <a:spAutoFit/>
-          </a:bodyPr>
-          <a:lstStyle/>
-          <a:p>
-            <a:pPr algn="l">
-              <a:spcAft>
-                <a:spcPts val="400"/>
-              </a:spcAft>
-            </a:pPr>
-            <a:r>
-              <a:rPr sz="1400" b="1">
-                <a:solidFill>
-                  <a:srgbClr val="B4760A"/>
-                </a:solidFill>
-                <a:latin typeface="맑은 고딕"/>
-              </a:rPr>
-              <a:t>50K 연장은 중단했다</a:t>
-            </a:r>
-          </a:p>
-          <a:p>
-            <a:pPr algn="l">
-              <a:spcAft>
-                <a:spcPts val="300"/>
-              </a:spcAft>
-            </a:pPr>
-            <a:r>
-              <a:rPr sz="1250" b="0">
-                <a:solidFill>
-                  <a:srgbClr val="20262E"/>
-                </a:solidFill>
-                <a:latin typeface="맑은 고딕"/>
-              </a:rPr>
-              <a:t>10K → 30K가 held-out을 하나도 개선하지 못했다.</a:t>
-            </a:r>
-          </a:p>
-          <a:p>
-            <a:pPr algn="l">
-              <a:spcAft>
-                <a:spcPts val="300"/>
-              </a:spcAft>
-            </a:pPr>
-            <a:r>
-              <a:rPr sz="1250" b="0">
-                <a:solidFill>
-                  <a:srgbClr val="20262E"/>
-                </a:solidFill>
-                <a:latin typeface="맑은 고딕"/>
-              </a:rPr>
-              <a:t>게다가 resume은 웜 리스타트다 — lr_lambdas가 [{}]로만 저장돼</a:t>
-            </a:r>
-          </a:p>
-          <a:p>
-            <a:pPr algn="l">
-              <a:spcAft>
-                <a:spcPts val="300"/>
-              </a:spcAft>
-            </a:pPr>
-            <a:r>
-              <a:rPr sz="1250" b="0">
-                <a:solidFill>
-                  <a:srgbClr val="20262E"/>
-                </a:solidFill>
-                <a:latin typeface="맑은 고딕"/>
-              </a:rPr>
-              <a:t>새 50K 코사인이 적용되고 LR이 ~0 → 3.77e-5로 되올라간다(실측).</a:t>
-            </a:r>
-          </a:p>
-          <a:p>
-            <a:pPr algn="l">
-              <a:spcAft>
-                <a:spcPts val="300"/>
-              </a:spcAft>
-            </a:pPr>
-            <a:r>
-              <a:rPr sz="1250" b="0">
-                <a:solidFill>
-                  <a:srgbClr val="20262E"/>
-                </a:solidFill>
-                <a:latin typeface="맑은 고딕"/>
-              </a:rPr>
-              <a:t>과적합 구간에서 LR을 다시 올리는 셈.</a:t>
-            </a:r>
-          </a:p>
-        </p:txBody>
-      </p:sp>
-      <p:sp>
-        <p:nvSpPr>
-          <p:cNvPr id="11" name="Rounded Rectangle 10"/>
+          <p:cNvPr id="4" name="Rounded Rectangle 3"/>
           <p:cNvSpPr/>
           <p:nvPr/>
         </p:nvSpPr>
         <p:spPr>
           <a:xfrm>
             <a:off x="566928" y="5120640"/>
-            <a:ext cx="11057839" cy="960120"/>
+            <a:ext cx="11057839" cy="1051560"/>
           </a:xfrm>
           <a:prstGeom prst="roundRect">
             <a:avLst>
@@ -11164,14 +10871,14 @@
       </p:sp>
       <p:sp>
         <p:nvSpPr>
-          <p:cNvPr id="12" name="Rectangle 11"/>
+          <p:cNvPr id="5" name="Rectangle 4"/>
           <p:cNvSpPr/>
           <p:nvPr/>
         </p:nvSpPr>
         <p:spPr>
           <a:xfrm>
             <a:off x="566928" y="5120640"/>
-            <a:ext cx="64008" cy="960120"/>
+            <a:ext cx="64008" cy="1051560"/>
           </a:xfrm>
           <a:prstGeom prst="rect">
             <a:avLst/>
@@ -11208,14 +10915,14 @@
       </p:sp>
       <p:sp>
         <p:nvSpPr>
-          <p:cNvPr id="13" name="TextBox 12"/>
+          <p:cNvPr id="6" name="TextBox 5"/>
           <p:cNvSpPr txBox="1"/>
           <p:nvPr/>
         </p:nvSpPr>
         <p:spPr>
           <a:xfrm>
             <a:off x="768096" y="5212080"/>
-            <a:ext cx="10692079" cy="777240"/>
+            <a:ext cx="10692079" cy="868680"/>
           </a:xfrm>
           <a:prstGeom prst="rect">
             <a:avLst/>
@@ -11240,7 +10947,7 @@
                 </a:solidFill>
                 <a:latin typeface="맑은 고딕"/>
               </a:rPr>
-              <a:t>그래서 다음 레버는 스텝이 아니라 데이터다</a:t>
+              <a:t>목표치를 굳이 잡자면</a:t>
             </a:r>
           </a:p>
           <a:p>
@@ -11256,7 +10963,7 @@
                 </a:solidFill>
                 <a:latin typeface="맑은 고딕"/>
               </a:rPr>
-              <a:t>81 에피소드에서 10,000 스텝(45 epoch)이면 이 데이터로 배울 건 다 배웠다는 뜻이다.</a:t>
+              <a:t>분기당 40~60개, 총 120~160 에피소드가 논문 레시피와 맞는 규모다. 지금 81개는 “주 동작은 학습되지만 조건 분기는 부족할 수 있다”는 위치.</a:t>
             </a:r>
           </a:p>
           <a:p>
@@ -11272,14 +10979,14 @@
                 </a:solidFill>
                 <a:latin typeface="맑은 고딕"/>
               </a:rPr>
-              <a:t>→ 초기 송장 위치 분포를 세고, 부족한 분기를 집중 수집한다 (§6.3).</a:t>
+              <a:t>정밀 접촉 작업을 하게 되면 그때는 10 fps도 재고 대상 (1스텝 = 100 ms).</a:t>
             </a:r>
           </a:p>
         </p:txBody>
       </p:sp>
       <p:sp>
         <p:nvSpPr>
-          <p:cNvPr id="14" name="TextBox 13"/>
+          <p:cNvPr id="7" name="TextBox 6"/>
           <p:cNvSpPr txBox="1"/>
           <p:nvPr/>
         </p:nvSpPr>
@@ -11311,7 +11018,7 @@
                 </a:solidFill>
                 <a:latin typeface="맑은 고딕"/>
               </a:rPr>
-              <a:t>1차 결과</a:t>
+              <a:t>to-do</a:t>
             </a:r>
             <a:r>
               <a:rPr sz="1000" b="0">
@@ -11395,7 +11102,7 @@
                 </a:solidFill>
                 <a:latin typeface="맑은 고딕"/>
               </a:rPr>
-              <a:t>To-do</a:t>
+              <a:t>열린 질문</a:t>
             </a:r>
           </a:p>
           <a:p>
@@ -11411,7 +11118,7 @@
                 </a:solidFill>
                 <a:latin typeface="맑은 고딕"/>
               </a:rPr>
-              <a:t>지금 / 학습 후 / 다음 데이터</a:t>
+              <a:t>결정을 바꿀 수 있는 것들</a:t>
             </a:r>
           </a:p>
         </p:txBody>
@@ -11426,1000 +11133,7 @@
         </p:nvGraphicFramePr>
         <p:xfrm>
           <a:off x="566928" y="1389888"/>
-          <a:ext cx="11057837" cy="3072384"/>
-        </p:xfrm>
-        <a:graphic>
-          <a:graphicData uri="http://schemas.openxmlformats.org/drawingml/2006/table">
-            <a:tbl>
-              <a:tblPr firstRow="1" bandRow="1">
-                <a:tableStyleId>{5C22544A-7EE6-4342-B048-85BDC9FD1C3A}</a:tableStyleId>
-              </a:tblPr>
-              <a:tblGrid>
-                <a:gridCol w="1734562"/>
-                <a:gridCol w="4986868"/>
-                <a:gridCol w="4336407"/>
-              </a:tblGrid>
-              <a:tr h="384048">
-                <a:tc>
-                  <a:txBody>
-                    <a:bodyPr wrap="square"/>
-                    <a:lstStyle/>
-                    <a:p>
-                      <a:pPr algn="l">
-                        <a:spcAft>
-                          <a:spcPts val="0"/>
-                        </a:spcAft>
-                      </a:pPr>
-                      <a:r>
-                        <a:rPr sz="1200" b="1">
-                          <a:solidFill>
-                            <a:srgbClr val="FFFFFF"/>
-                          </a:solidFill>
-                          <a:latin typeface="맑은 고딕"/>
-                        </a:rPr>
-                        <a:t>시점</a:t>
-                      </a:r>
-                    </a:p>
-                  </a:txBody>
-                  <a:tcPr marL="73152" marR="73152" marT="18288" marB="18288" anchor="ctr">
-                    <a:solidFill>
-                      <a:srgbClr val="1B3A5C"/>
-                    </a:solidFill>
-                  </a:tcPr>
-                </a:tc>
-                <a:tc>
-                  <a:txBody>
-                    <a:bodyPr wrap="square"/>
-                    <a:lstStyle/>
-                    <a:p>
-                      <a:pPr algn="l">
-                        <a:spcAft>
-                          <a:spcPts val="0"/>
-                        </a:spcAft>
-                      </a:pPr>
-                      <a:r>
-                        <a:rPr sz="1200" b="1">
-                          <a:solidFill>
-                            <a:srgbClr val="FFFFFF"/>
-                          </a:solidFill>
-                          <a:latin typeface="맑은 고딕"/>
-                        </a:rPr>
-                        <a:t>할 일</a:t>
-                      </a:r>
-                    </a:p>
-                  </a:txBody>
-                  <a:tcPr marL="73152" marR="73152" marT="18288" marB="18288" anchor="ctr">
-                    <a:solidFill>
-                      <a:srgbClr val="1B3A5C"/>
-                    </a:solidFill>
-                  </a:tcPr>
-                </a:tc>
-                <a:tc>
-                  <a:txBody>
-                    <a:bodyPr wrap="square"/>
-                    <a:lstStyle/>
-                    <a:p>
-                      <a:pPr algn="l">
-                        <a:spcAft>
-                          <a:spcPts val="0"/>
-                        </a:spcAft>
-                      </a:pPr>
-                      <a:r>
-                        <a:rPr sz="1200" b="1">
-                          <a:solidFill>
-                            <a:srgbClr val="FFFFFF"/>
-                          </a:solidFill>
-                          <a:latin typeface="맑은 고딕"/>
-                        </a:rPr>
-                        <a:t>왜</a:t>
-                      </a:r>
-                    </a:p>
-                  </a:txBody>
-                  <a:tcPr marL="73152" marR="73152" marT="18288" marB="18288" anchor="ctr">
-                    <a:solidFill>
-                      <a:srgbClr val="1B3A5C"/>
-                    </a:solidFill>
-                  </a:tcPr>
-                </a:tc>
-              </a:tr>
-              <a:tr h="384048">
-                <a:tc>
-                  <a:txBody>
-                    <a:bodyPr wrap="square"/>
-                    <a:lstStyle/>
-                    <a:p>
-                      <a:pPr algn="l">
-                        <a:spcAft>
-                          <a:spcPts val="0"/>
-                        </a:spcAft>
-                      </a:pPr>
-                      <a:r>
-                        <a:rPr sz="1200" b="1">
-                          <a:solidFill>
-                            <a:srgbClr val="20262E"/>
-                          </a:solidFill>
-                          <a:latin typeface="맑은 고딕"/>
-                        </a:rPr>
-                        <a:t>학습 도는 동안</a:t>
-                      </a:r>
-                    </a:p>
-                  </a:txBody>
-                  <a:tcPr marL="73152" marR="73152" marT="18288" marB="18288" anchor="ctr">
-                    <a:solidFill>
-                      <a:srgbClr val="FFFFFF"/>
-                    </a:solidFill>
-                  </a:tcPr>
-                </a:tc>
-                <a:tc>
-                  <a:txBody>
-                    <a:bodyPr wrap="square"/>
-                    <a:lstStyle/>
-                    <a:p>
-                      <a:pPr algn="l">
-                        <a:spcAft>
-                          <a:spcPts val="0"/>
-                        </a:spcAft>
-                      </a:pPr>
-                      <a:r>
-                        <a:rPr sz="1200" b="0">
-                          <a:solidFill>
-                            <a:srgbClr val="20262E"/>
-                          </a:solidFill>
-                          <a:latin typeface="맑은 고딕"/>
-                        </a:rPr>
-                        <a:t>배포 클라이언트의 26 → 57 관절 매핑 갱신</a:t>
-                      </a:r>
-                    </a:p>
-                  </a:txBody>
-                  <a:tcPr marL="73152" marR="73152" marT="18288" marB="18288" anchor="ctr">
-                    <a:solidFill>
-                      <a:srgbClr val="FFFFFF"/>
-                    </a:solidFill>
-                  </a:tcPr>
-                </a:tc>
-                <a:tc>
-                  <a:txBody>
-                    <a:bodyPr wrap="square"/>
-                    <a:lstStyle/>
-                    <a:p>
-                      <a:pPr algn="l">
-                        <a:spcAft>
-                          <a:spcPts val="0"/>
-                        </a:spcAft>
-                      </a:pPr>
-                      <a:r>
-                        <a:rPr sz="1200" b="0">
-                          <a:solidFill>
-                            <a:srgbClr val="20262E"/>
-                          </a:solidFill>
-                          <a:latin typeface="맑은 고딕"/>
-                        </a:rPr>
-                        <a:t>서버 출력 키가 바뀐다. 유일하게 한 번도 안 띄워본 경로</a:t>
-                      </a:r>
-                    </a:p>
-                  </a:txBody>
-                  <a:tcPr marL="73152" marR="73152" marT="18288" marB="18288" anchor="ctr">
-                    <a:solidFill>
-                      <a:srgbClr val="FFFFFF"/>
-                    </a:solidFill>
-                  </a:tcPr>
-                </a:tc>
-              </a:tr>
-              <a:tr h="384048">
-                <a:tc>
-                  <a:txBody>
-                    <a:bodyPr wrap="square"/>
-                    <a:lstStyle/>
-                    <a:p>
-                      <a:pPr algn="l">
-                        <a:spcAft>
-                          <a:spcPts val="0"/>
-                        </a:spcAft>
-                      </a:pPr>
-                      <a:r>
-                        <a:rPr sz="1200" b="0">
-                          <a:solidFill>
-                            <a:srgbClr val="20262E"/>
-                          </a:solidFill>
-                          <a:latin typeface="맑은 고딕"/>
-                        </a:rPr>
-                        <a:t/>
-                      </a:r>
-                    </a:p>
-                  </a:txBody>
-                  <a:tcPr marL="73152" marR="73152" marT="18288" marB="18288" anchor="ctr">
-                    <a:solidFill>
-                      <a:srgbClr val="F2F5F8"/>
-                    </a:solidFill>
-                  </a:tcPr>
-                </a:tc>
-                <a:tc>
-                  <a:txBody>
-                    <a:bodyPr wrap="square"/>
-                    <a:lstStyle/>
-                    <a:p>
-                      <a:pPr algn="l">
-                        <a:spcAft>
-                          <a:spcPts val="0"/>
-                        </a:spcAft>
-                      </a:pPr>
-                      <a:r>
-                        <a:rPr sz="1200" b="0">
-                          <a:solidFill>
-                            <a:srgbClr val="20262E"/>
-                          </a:solidFill>
-                          <a:latin typeface="맑은 고딕"/>
-                        </a:rPr>
-                        <a:t>데이터팀 확인: 초기 송장 위치 분포 (front/top/hidden/side)</a:t>
-                      </a:r>
-                    </a:p>
-                  </a:txBody>
-                  <a:tcPr marL="73152" marR="73152" marT="18288" marB="18288" anchor="ctr">
-                    <a:solidFill>
-                      <a:srgbClr val="F2F5F8"/>
-                    </a:solidFill>
-                  </a:tcPr>
-                </a:tc>
-                <a:tc>
-                  <a:txBody>
-                    <a:bodyPr wrap="square"/>
-                    <a:lstStyle/>
-                    <a:p>
-                      <a:pPr algn="l">
-                        <a:spcAft>
-                          <a:spcPts val="0"/>
-                        </a:spcAft>
-                      </a:pPr>
-                      <a:r>
-                        <a:rPr sz="1200" b="0">
-                          <a:solidFill>
-                            <a:srgbClr val="20262E"/>
-                          </a:solidFill>
-                          <a:latin typeface="맑은 고딕"/>
-                        </a:rPr>
-                        <a:t>분기 균형을 모르면 소수 분기가 학습되지 않는다</a:t>
-                      </a:r>
-                    </a:p>
-                  </a:txBody>
-                  <a:tcPr marL="73152" marR="73152" marT="18288" marB="18288" anchor="ctr">
-                    <a:solidFill>
-                      <a:srgbClr val="F2F5F8"/>
-                    </a:solidFill>
-                  </a:tcPr>
-                </a:tc>
-              </a:tr>
-              <a:tr h="384048">
-                <a:tc>
-                  <a:txBody>
-                    <a:bodyPr wrap="square"/>
-                    <a:lstStyle/>
-                    <a:p>
-                      <a:pPr algn="l">
-                        <a:spcAft>
-                          <a:spcPts val="0"/>
-                        </a:spcAft>
-                      </a:pPr>
-                      <a:r>
-                        <a:rPr sz="1200" b="1">
-                          <a:solidFill>
-                            <a:srgbClr val="20262E"/>
-                          </a:solidFill>
-                          <a:latin typeface="맑은 고딕"/>
-                        </a:rPr>
-                        <a:t>학습 직후</a:t>
-                      </a:r>
-                    </a:p>
-                  </a:txBody>
-                  <a:tcPr marL="73152" marR="73152" marT="18288" marB="18288" anchor="ctr">
-                    <a:solidFill>
-                      <a:srgbClr val="FFFFFF"/>
-                    </a:solidFill>
-                  </a:tcPr>
-                </a:tc>
-                <a:tc>
-                  <a:txBody>
-                    <a:bodyPr wrap="square"/>
-                    <a:lstStyle/>
-                    <a:p>
-                      <a:pPr algn="l">
-                        <a:spcAft>
-                          <a:spcPts val="0"/>
-                        </a:spcAft>
-                      </a:pPr>
-                      <a:r>
-                        <a:rPr sz="1200" b="0">
-                          <a:solidFill>
-                            <a:srgbClr val="20262E"/>
-                          </a:solidFill>
-                          <a:latin typeface="맑은 고딕"/>
-                        </a:rPr>
-                        <a:t>10K / 20K / 30K를 held-out으로 평가 → 최저 MSE 선택</a:t>
-                      </a:r>
-                    </a:p>
-                  </a:txBody>
-                  <a:tcPr marL="73152" marR="73152" marT="18288" marB="18288" anchor="ctr">
-                    <a:solidFill>
-                      <a:srgbClr val="FFFFFF"/>
-                    </a:solidFill>
-                  </a:tcPr>
-                </a:tc>
-                <a:tc>
-                  <a:txBody>
-                    <a:bodyPr wrap="square"/>
-                    <a:lstStyle/>
-                    <a:p>
-                      <a:pPr algn="l">
-                        <a:spcAft>
-                          <a:spcPts val="0"/>
-                        </a:spcAft>
-                      </a:pPr>
-                      <a:r>
-                        <a:rPr sz="1200" b="0">
-                          <a:solidFill>
-                            <a:srgbClr val="20262E"/>
-                          </a:solidFill>
-                          <a:latin typeface="맑은 고딕"/>
-                        </a:rPr>
-                        <a:t>validation이 없어 train loss만으로는 과적합을 못 본다</a:t>
-                      </a:r>
-                    </a:p>
-                  </a:txBody>
-                  <a:tcPr marL="73152" marR="73152" marT="18288" marB="18288" anchor="ctr">
-                    <a:solidFill>
-                      <a:srgbClr val="FFFFFF"/>
-                    </a:solidFill>
-                  </a:tcPr>
-                </a:tc>
-              </a:tr>
-              <a:tr h="384048">
-                <a:tc>
-                  <a:txBody>
-                    <a:bodyPr wrap="square"/>
-                    <a:lstStyle/>
-                    <a:p>
-                      <a:pPr algn="l">
-                        <a:spcAft>
-                          <a:spcPts val="0"/>
-                        </a:spcAft>
-                      </a:pPr>
-                      <a:r>
-                        <a:rPr sz="1200" b="0">
-                          <a:solidFill>
-                            <a:srgbClr val="20262E"/>
-                          </a:solidFill>
-                          <a:latin typeface="맑은 고딕"/>
-                        </a:rPr>
-                        <a:t/>
-                      </a:r>
-                    </a:p>
-                  </a:txBody>
-                  <a:tcPr marL="73152" marR="73152" marT="18288" marB="18288" anchor="ctr">
-                    <a:solidFill>
-                      <a:srgbClr val="F2F5F8"/>
-                    </a:solidFill>
-                  </a:tcPr>
-                </a:tc>
-                <a:tc>
-                  <a:txBody>
-                    <a:bodyPr wrap="square"/>
-                    <a:lstStyle/>
-                    <a:p>
-                      <a:pPr algn="l">
-                        <a:spcAft>
-                          <a:spcPts val="0"/>
-                        </a:spcAft>
-                      </a:pPr>
-                      <a:r>
-                        <a:rPr sz="1200" b="0">
-                          <a:solidFill>
-                            <a:srgbClr val="20262E"/>
-                          </a:solidFill>
-                          <a:latin typeface="맑은 고딕"/>
-                        </a:rPr>
-                        <a:t>실기 롤아웃으로 실패 모드 관찰</a:t>
-                      </a:r>
-                    </a:p>
-                  </a:txBody>
-                  <a:tcPr marL="73152" marR="73152" marT="18288" marB="18288" anchor="ctr">
-                    <a:solidFill>
-                      <a:srgbClr val="F2F5F8"/>
-                    </a:solidFill>
-                  </a:tcPr>
-                </a:tc>
-                <a:tc>
-                  <a:txBody>
-                    <a:bodyPr wrap="square"/>
-                    <a:lstStyle/>
-                    <a:p>
-                      <a:pPr algn="l">
-                        <a:spcAft>
-                          <a:spcPts val="0"/>
-                        </a:spcAft>
-                      </a:pPr>
-                      <a:r>
-                        <a:rPr sz="1200" b="0">
-                          <a:solidFill>
-                            <a:srgbClr val="20262E"/>
-                          </a:solidFill>
-                          <a:latin typeface="맑은 고딕"/>
-                        </a:rPr>
-                        <a:t>“전 구간 어설픔”인가 “전환 지점에서 멈춤”인가</a:t>
-                      </a:r>
-                    </a:p>
-                  </a:txBody>
-                  <a:tcPr marL="73152" marR="73152" marT="18288" marB="18288" anchor="ctr">
-                    <a:solidFill>
-                      <a:srgbClr val="F2F5F8"/>
-                    </a:solidFill>
-                  </a:tcPr>
-                </a:tc>
-              </a:tr>
-              <a:tr h="384048">
-                <a:tc>
-                  <a:txBody>
-                    <a:bodyPr wrap="square"/>
-                    <a:lstStyle/>
-                    <a:p>
-                      <a:pPr algn="l">
-                        <a:spcAft>
-                          <a:spcPts val="0"/>
-                        </a:spcAft>
-                      </a:pPr>
-                      <a:r>
-                        <a:rPr sz="1200" b="0">
-                          <a:solidFill>
-                            <a:srgbClr val="20262E"/>
-                          </a:solidFill>
-                          <a:latin typeface="맑은 고딕"/>
-                        </a:rPr>
-                        <a:t/>
-                      </a:r>
-                    </a:p>
-                  </a:txBody>
-                  <a:tcPr marL="73152" marR="73152" marT="18288" marB="18288" anchor="ctr">
-                    <a:solidFill>
-                      <a:srgbClr val="FFFFFF"/>
-                    </a:solidFill>
-                  </a:tcPr>
-                </a:tc>
-                <a:tc>
-                  <a:txBody>
-                    <a:bodyPr wrap="square"/>
-                    <a:lstStyle/>
-                    <a:p>
-                      <a:pPr algn="l">
-                        <a:spcAft>
-                          <a:spcPts val="0"/>
-                        </a:spcAft>
-                      </a:pPr>
-                      <a:r>
-                        <a:rPr sz="1200" b="0">
-                          <a:solidFill>
-                            <a:srgbClr val="20262E"/>
-                          </a:solidFill>
-                          <a:latin typeface="맑은 고딕"/>
-                        </a:rPr>
-                        <a:t>배포 시 40 중 20만 실행 (2.0초), 여유되면 RTC guided</a:t>
-                      </a:r>
-                    </a:p>
-                  </a:txBody>
-                  <a:tcPr marL="73152" marR="73152" marT="18288" marB="18288" anchor="ctr">
-                    <a:solidFill>
-                      <a:srgbClr val="FFFFFF"/>
-                    </a:solidFill>
-                  </a:tcPr>
-                </a:tc>
-                <a:tc>
-                  <a:txBody>
-                    <a:bodyPr wrap="square"/>
-                    <a:lstStyle/>
-                    <a:p>
-                      <a:pPr algn="l">
-                        <a:spcAft>
-                          <a:spcPts val="0"/>
-                        </a:spcAft>
-                      </a:pPr>
-                      <a:r>
-                        <a:rPr sz="1200" b="0">
-                          <a:solidFill>
-                            <a:srgbClr val="20262E"/>
-                          </a:solidFill>
-                          <a:latin typeface="맑은 고딕"/>
-                        </a:rPr>
-                        <a:t>16개 전부 = 4초 open-loop는 컨베이어에서 길다</a:t>
-                      </a:r>
-                    </a:p>
-                  </a:txBody>
-                  <a:tcPr marL="73152" marR="73152" marT="18288" marB="18288" anchor="ctr">
-                    <a:solidFill>
-                      <a:srgbClr val="FFFFFF"/>
-                    </a:solidFill>
-                  </a:tcPr>
-                </a:tc>
-              </a:tr>
-              <a:tr h="384048">
-                <a:tc>
-                  <a:txBody>
-                    <a:bodyPr wrap="square"/>
-                    <a:lstStyle/>
-                    <a:p>
-                      <a:pPr algn="l">
-                        <a:spcAft>
-                          <a:spcPts val="0"/>
-                        </a:spcAft>
-                      </a:pPr>
-                      <a:r>
-                        <a:rPr sz="1200" b="1">
-                          <a:solidFill>
-                            <a:srgbClr val="20262E"/>
-                          </a:solidFill>
-                          <a:latin typeface="맑은 고딕"/>
-                        </a:rPr>
-                        <a:t>다음 데이터</a:t>
-                      </a:r>
-                    </a:p>
-                  </a:txBody>
-                  <a:tcPr marL="73152" marR="73152" marT="18288" marB="18288" anchor="ctr">
-                    <a:solidFill>
-                      <a:srgbClr val="F2F5F8"/>
-                    </a:solidFill>
-                  </a:tcPr>
-                </a:tc>
-                <a:tc>
-                  <a:txBody>
-                    <a:bodyPr wrap="square"/>
-                    <a:lstStyle/>
-                    <a:p>
-                      <a:pPr algn="l">
-                        <a:spcAft>
-                          <a:spcPts val="0"/>
-                        </a:spcAft>
-                      </a:pPr>
-                      <a:r>
-                        <a:rPr sz="1200" b="0">
-                          <a:solidFill>
-                            <a:srgbClr val="20262E"/>
-                          </a:solidFill>
-                          <a:latin typeface="맑은 고딕"/>
-                        </a:rPr>
-                        <a:t>부족한 분기를 골라 집중 수집 (논문 §4.3 adaptive collection)</a:t>
-                      </a:r>
-                    </a:p>
-                  </a:txBody>
-                  <a:tcPr marL="73152" marR="73152" marT="18288" marB="18288" anchor="ctr">
-                    <a:solidFill>
-                      <a:srgbClr val="F2F5F8"/>
-                    </a:solidFill>
-                  </a:tcPr>
-                </a:tc>
-                <a:tc>
-                  <a:txBody>
-                    <a:bodyPr wrap="square"/>
-                    <a:lstStyle/>
-                    <a:p>
-                      <a:pPr algn="l">
-                        <a:spcAft>
-                          <a:spcPts val="0"/>
-                        </a:spcAft>
-                      </a:pPr>
-                      <a:r>
-                        <a:rPr sz="1200" b="0">
-                          <a:solidFill>
-                            <a:srgbClr val="20262E"/>
-                          </a:solidFill>
-                          <a:latin typeface="맑은 고딕"/>
-                        </a:rPr>
-                        <a:t>무작정 늘리는 것보다 효율이 높다고 보고됨</a:t>
-                      </a:r>
-                    </a:p>
-                  </a:txBody>
-                  <a:tcPr marL="73152" marR="73152" marT="18288" marB="18288" anchor="ctr">
-                    <a:solidFill>
-                      <a:srgbClr val="F2F5F8"/>
-                    </a:solidFill>
-                  </a:tcPr>
-                </a:tc>
-              </a:tr>
-              <a:tr h="384048">
-                <a:tc>
-                  <a:txBody>
-                    <a:bodyPr wrap="square"/>
-                    <a:lstStyle/>
-                    <a:p>
-                      <a:pPr algn="l">
-                        <a:spcAft>
-                          <a:spcPts val="0"/>
-                        </a:spcAft>
-                      </a:pPr>
-                      <a:r>
-                        <a:rPr sz="1200" b="0">
-                          <a:solidFill>
-                            <a:srgbClr val="20262E"/>
-                          </a:solidFill>
-                          <a:latin typeface="맑은 고딕"/>
-                        </a:rPr>
-                        <a:t/>
-                      </a:r>
-                    </a:p>
-                  </a:txBody>
-                  <a:tcPr marL="73152" marR="73152" marT="18288" marB="18288" anchor="ctr">
-                    <a:solidFill>
-                      <a:srgbClr val="FFFFFF"/>
-                    </a:solidFill>
-                  </a:tcPr>
-                </a:tc>
-                <a:tc>
-                  <a:txBody>
-                    <a:bodyPr wrap="square"/>
-                    <a:lstStyle/>
-                    <a:p>
-                      <a:pPr algn="l">
-                        <a:spcAft>
-                          <a:spcPts val="0"/>
-                        </a:spcAft>
-                      </a:pPr>
-                      <a:r>
-                        <a:rPr sz="1200" b="0">
-                          <a:solidFill>
-                            <a:srgbClr val="20262E"/>
-                          </a:solidFill>
-                          <a:latin typeface="맑은 고딕"/>
-                        </a:rPr>
-                        <a:t>필요해지면 subtask 도입 (B) — 코드는 이미 지원</a:t>
-                      </a:r>
-                    </a:p>
-                  </a:txBody>
-                  <a:tcPr marL="73152" marR="73152" marT="18288" marB="18288" anchor="ctr">
-                    <a:solidFill>
-                      <a:srgbClr val="FFFFFF"/>
-                    </a:solidFill>
-                  </a:tcPr>
-                </a:tc>
-                <a:tc>
-                  <a:txBody>
-                    <a:bodyPr wrap="square"/>
-                    <a:lstStyle/>
-                    <a:p>
-                      <a:pPr algn="l">
-                        <a:spcAft>
-                          <a:spcPts val="0"/>
-                        </a:spcAft>
-                      </a:pPr>
-                      <a:r>
-                        <a:rPr sz="1200" b="0">
-                          <a:solidFill>
-                            <a:srgbClr val="20262E"/>
-                          </a:solidFill>
-                          <a:latin typeface="맑은 고딕"/>
-                        </a:rPr>
-                        <a:t>1차 실패 모드가 “전환 지점”으로 나올 때만</a:t>
-                      </a:r>
-                    </a:p>
-                  </a:txBody>
-                  <a:tcPr marL="73152" marR="73152" marT="18288" marB="18288" anchor="ctr">
-                    <a:solidFill>
-                      <a:srgbClr val="FFFFFF"/>
-                    </a:solidFill>
-                  </a:tcPr>
-                </a:tc>
-              </a:tr>
-            </a:tbl>
-          </a:graphicData>
-        </a:graphic>
-      </p:graphicFrame>
-      <p:sp>
-        <p:nvSpPr>
-          <p:cNvPr id="4" name="Rounded Rectangle 3"/>
-          <p:cNvSpPr/>
-          <p:nvPr/>
-        </p:nvSpPr>
-        <p:spPr>
-          <a:xfrm>
-            <a:off x="566928" y="5120640"/>
-            <a:ext cx="11057839" cy="1051560"/>
-          </a:xfrm>
-          <a:prstGeom prst="roundRect">
-            <a:avLst>
-              <a:gd name="adj" fmla="val 4000"/>
-            </a:avLst>
-          </a:prstGeom>
-          <a:solidFill>
-            <a:srgbClr val="F2F5F8"/>
-          </a:solidFill>
-          <a:ln w="19050">
-            <a:solidFill>
-              <a:srgbClr val="1B3A5C"/>
-            </a:solidFill>
-          </a:ln>
-          <a:effectLst/>
-        </p:spPr>
-        <p:style>
-          <a:lnRef idx="1">
-            <a:schemeClr val="accent1"/>
-          </a:lnRef>
-          <a:fillRef idx="3">
-            <a:schemeClr val="accent1"/>
-          </a:fillRef>
-          <a:effectRef idx="2">
-            <a:schemeClr val="accent1"/>
-          </a:effectRef>
-          <a:fontRef idx="minor">
-            <a:schemeClr val="lt1"/>
-          </a:fontRef>
-        </p:style>
-        <p:txBody>
-          <a:bodyPr rtlCol="0" anchor="ctr"/>
-          <a:lstStyle/>
-          <a:p>
-            <a:pPr algn="ctr"/>
-          </a:p>
-        </p:txBody>
-      </p:sp>
-      <p:sp>
-        <p:nvSpPr>
-          <p:cNvPr id="5" name="Rectangle 4"/>
-          <p:cNvSpPr/>
-          <p:nvPr/>
-        </p:nvSpPr>
-        <p:spPr>
-          <a:xfrm>
-            <a:off x="566928" y="5120640"/>
-            <a:ext cx="64008" cy="1051560"/>
-          </a:xfrm>
-          <a:prstGeom prst="rect">
-            <a:avLst/>
-          </a:prstGeom>
-          <a:solidFill>
-            <a:srgbClr val="1B3A5C"/>
-          </a:solidFill>
-          <a:ln>
-            <a:noFill/>
-          </a:ln>
-          <a:effectLst/>
-        </p:spPr>
-        <p:style>
-          <a:lnRef idx="1">
-            <a:schemeClr val="accent1"/>
-          </a:lnRef>
-          <a:fillRef idx="3">
-            <a:schemeClr val="accent1"/>
-          </a:fillRef>
-          <a:effectRef idx="2">
-            <a:schemeClr val="accent1"/>
-          </a:effectRef>
-          <a:fontRef idx="minor">
-            <a:schemeClr val="lt1"/>
-          </a:fontRef>
-        </p:style>
-        <p:txBody>
-          <a:bodyPr rtlCol="0" anchor="ctr"/>
-          <a:lstStyle/>
-          <a:p>
-            <a:pPr algn="ctr"/>
-          </a:p>
-        </p:txBody>
-      </p:sp>
-      <p:sp>
-        <p:nvSpPr>
-          <p:cNvPr id="6" name="TextBox 5"/>
-          <p:cNvSpPr txBox="1"/>
-          <p:nvPr/>
-        </p:nvSpPr>
-        <p:spPr>
-          <a:xfrm>
-            <a:off x="768096" y="5212080"/>
-            <a:ext cx="10692079" cy="868680"/>
-          </a:xfrm>
-          <a:prstGeom prst="rect">
-            <a:avLst/>
-          </a:prstGeom>
-          <a:noFill/>
-        </p:spPr>
-        <p:txBody>
-          <a:bodyPr wrap="square">
-            <a:spAutoFit/>
-          </a:bodyPr>
-          <a:lstStyle/>
-          <a:p>
-            <a:pPr algn="l">
-              <a:spcAft>
-                <a:spcPts val="400"/>
-              </a:spcAft>
-            </a:pPr>
-            <a:r>
-              <a:rPr sz="1400" b="1">
-                <a:solidFill>
-                  <a:srgbClr val="1B3A5C"/>
-                </a:solidFill>
-                <a:latin typeface="맑은 고딕"/>
-              </a:rPr>
-              <a:t>목표치를 굳이 잡자면</a:t>
-            </a:r>
-          </a:p>
-          <a:p>
-            <a:pPr algn="l">
-              <a:spcAft>
-                <a:spcPts val="300"/>
-              </a:spcAft>
-            </a:pPr>
-            <a:r>
-              <a:rPr sz="1300" b="0">
-                <a:solidFill>
-                  <a:srgbClr val="20262E"/>
-                </a:solidFill>
-                <a:latin typeface="맑은 고딕"/>
-              </a:rPr>
-              <a:t>분기당 40~60개, 총 120~160 에피소드가 논문 레시피와 맞는 규모다. 지금 81개는 “주 동작은 학습되지만 조건 분기는 부족할 수 있다”는 위치.</a:t>
-            </a:r>
-          </a:p>
-          <a:p>
-            <a:pPr algn="l">
-              <a:spcAft>
-                <a:spcPts val="300"/>
-              </a:spcAft>
-            </a:pPr>
-            <a:r>
-              <a:rPr sz="1300" b="0">
-                <a:solidFill>
-                  <a:srgbClr val="20262E"/>
-                </a:solidFill>
-                <a:latin typeface="맑은 고딕"/>
-              </a:rPr>
-              <a:t>정밀 접촉 작업을 하게 되면 그때는 10 fps도 재고 대상 (1스텝 = 100 ms).</a:t>
-            </a:r>
-          </a:p>
-        </p:txBody>
-      </p:sp>
-      <p:sp>
-        <p:nvSpPr>
-          <p:cNvPr id="7" name="TextBox 6"/>
-          <p:cNvSpPr txBox="1"/>
-          <p:nvPr/>
-        </p:nvSpPr>
-        <p:spPr>
-          <a:xfrm>
-            <a:off x="566928" y="6437376"/>
-            <a:ext cx="11057839" cy="274320"/>
-          </a:xfrm>
-          <a:prstGeom prst="rect">
-            <a:avLst/>
-          </a:prstGeom>
-          <a:noFill/>
-        </p:spPr>
-        <p:txBody>
-          <a:bodyPr wrap="none">
-            <a:spAutoFit/>
-          </a:bodyPr>
-          <a:lstStyle/>
-          <a:p>
-            <a:pPr algn="l">
-              <a:spcAft>
-                <a:spcPts val="0"/>
-              </a:spcAft>
-            </a:pPr>
-            <a:r>
-              <a:rPr sz="1000" b="0">
-                <a:solidFill>
-                  <a:srgbClr val="5A636E"/>
-                </a:solidFill>
-                <a:latin typeface="맑은 고딕"/>
-              </a:rPr>
-              <a:t>to-do</a:t>
-            </a:r>
-            <a:r>
-              <a:rPr sz="1000" b="0">
-                <a:solidFill>
-                  <a:srgbClr val="5A636E"/>
-                </a:solidFill>
-                <a:latin typeface="맑은 고딕"/>
-              </a:rPr>
-              <a:t>          15</a:t>
-            </a:r>
-          </a:p>
-        </p:txBody>
-      </p:sp>
-    </p:spTree>
-  </p:cSld>
-  <p:clrMapOvr>
-    <a:masterClrMapping/>
-  </p:clrMapOvr>
-</p:sld>
-</file>
-
-<file path=ppt/slides/slide17.xml><?xml version="1.0" encoding="utf-8"?>
-<p:sld xmlns:a="http://schemas.openxmlformats.org/drawingml/2006/main" xmlns:p="http://schemas.openxmlformats.org/presentationml/2006/main" xmlns:r="http://schemas.openxmlformats.org/officeDocument/2006/relationships">
-  <p:cSld>
-    <p:spTree>
-      <p:nvGrpSpPr>
-        <p:cNvPr id="1" name=""/>
-        <p:cNvGrpSpPr/>
-        <p:nvPr/>
-      </p:nvGrpSpPr>
-      <p:grpSpPr/>
-      <p:sp>
-        <p:nvSpPr>
-          <p:cNvPr id="2" name="Rectangle 1"/>
-          <p:cNvSpPr/>
-          <p:nvPr/>
-        </p:nvSpPr>
-        <p:spPr>
-          <a:xfrm>
-            <a:off x="0" y="0"/>
-            <a:ext cx="12191695" cy="1060704"/>
-          </a:xfrm>
-          <a:prstGeom prst="rect">
-            <a:avLst/>
-          </a:prstGeom>
-          <a:solidFill>
-            <a:srgbClr val="1B3A5C"/>
-          </a:solidFill>
-          <a:ln>
-            <a:noFill/>
-          </a:ln>
-          <a:effectLst/>
-        </p:spPr>
-        <p:style>
-          <a:lnRef idx="1">
-            <a:schemeClr val="accent1"/>
-          </a:lnRef>
-          <a:fillRef idx="3">
-            <a:schemeClr val="accent1"/>
-          </a:fillRef>
-          <a:effectRef idx="2">
-            <a:schemeClr val="accent1"/>
-          </a:effectRef>
-          <a:fontRef idx="minor">
-            <a:schemeClr val="lt1"/>
-          </a:fontRef>
-        </p:style>
-        <p:txBody>
-          <a:bodyPr rtlCol="0" anchor="ctr" lIns="566928" tIns="146304"/>
-          <a:lstStyle/>
-          <a:p>
-            <a:pPr algn="l">
-              <a:spcAft>
-                <a:spcPts val="600"/>
-              </a:spcAft>
-            </a:pPr>
-            <a:r>
-              <a:rPr sz="2500" b="1">
-                <a:solidFill>
-                  <a:srgbClr val="FFFFFF"/>
-                </a:solidFill>
-                <a:latin typeface="맑은 고딕"/>
-              </a:rPr>
-              <a:t>열린 질문</a:t>
-            </a:r>
-          </a:p>
-          <a:p>
-            <a:pPr algn="l">
-              <a:spcAft>
-                <a:spcPts val="0"/>
-              </a:spcAft>
-            </a:pPr>
-            <a:r>
-              <a:rPr sz="1250" b="0">
-                <a:solidFill>
-                  <a:srgbClr val="B8CEE0"/>
-                </a:solidFill>
-                <a:latin typeface="맑은 고딕"/>
-              </a:rPr>
-              <a:t>결정을 바꿀 수 있는 것들</a:t>
-            </a:r>
-          </a:p>
-        </p:txBody>
-      </p:sp>
-      <p:graphicFrame>
-        <p:nvGraphicFramePr>
-          <p:cNvPr id="3" name="Table 2"/>
-          <p:cNvGraphicFramePr>
-            <a:graphicFrameLocks noGrp="1"/>
-          </p:cNvGraphicFramePr>
-          <p:nvPr/>
-        </p:nvGraphicFramePr>
-        <p:xfrm>
-          <a:off x="566928" y="1389888"/>
-          <a:ext cx="11057837" cy="2267712"/>
+          <a:ext cx="11057837" cy="3401568"/>
         </p:xfrm>
         <a:graphic>
           <a:graphicData uri="http://schemas.openxmlformats.org/drawingml/2006/table">
@@ -12511,6 +11225,172 @@
                   <a:tcPr marL="73152" marR="73152" marT="18288" marB="18288" anchor="ctr">
                     <a:solidFill>
                       <a:srgbClr val="1B3A5C"/>
+                    </a:solidFill>
+                  </a:tcPr>
+                </a:tc>
+              </a:tr>
+              <a:tr h="566928">
+                <a:tc>
+                  <a:txBody>
+                    <a:bodyPr wrap="square"/>
+                    <a:lstStyle/>
+                    <a:p>
+                      <a:pPr algn="l">
+                        <a:spcAft>
+                          <a:spcPts val="0"/>
+                        </a:spcAft>
+                      </a:pPr>
+                      <a:r>
+                        <a:rPr sz="1200" b="0">
+                          <a:solidFill>
+                            <a:srgbClr val="20262E"/>
+                          </a:solidFill>
+                          <a:latin typeface="맑은 고딕"/>
+                        </a:rPr>
+                        <a:t>tactile 센서 1~3번은 왜 무응답인가</a:t>
+                      </a:r>
+                    </a:p>
+                  </a:txBody>
+                  <a:tcPr marL="73152" marR="73152" marT="18288" marB="18288" anchor="ctr">
+                    <a:solidFill>
+                      <a:srgbClr val="FFFFFF"/>
+                    </a:solidFill>
+                  </a:tcPr>
+                </a:tc>
+                <a:tc>
+                  <a:txBody>
+                    <a:bodyPr wrap="square"/>
+                    <a:lstStyle/>
+                    <a:p>
+                      <a:pPr algn="l">
+                        <a:spcAft>
+                          <a:spcPts val="0"/>
+                        </a:spcAft>
+                      </a:pPr>
+                      <a:r>
+                        <a:rPr sz="1200" b="0">
+                          <a:solidFill>
+                            <a:srgbClr val="20262E"/>
+                          </a:solidFill>
+                          <a:latin typeface="맑은 고딕"/>
+                        </a:rPr>
+                        <a:t>33,018 프레임 내내 완전 0. 명령이 가는 손가락도 4·5번뿐이라 일관됨</a:t>
+                      </a:r>
+                    </a:p>
+                  </a:txBody>
+                  <a:tcPr marL="73152" marR="73152" marT="18288" marB="18288" anchor="ctr">
+                    <a:solidFill>
+                      <a:srgbClr val="FFFFFF"/>
+                    </a:solidFill>
+                  </a:tcPr>
+                </a:tc>
+                <a:tc>
+                  <a:txBody>
+                    <a:bodyPr wrap="square"/>
+                    <a:lstStyle/>
+                    <a:p>
+                      <a:pPr algn="l">
+                        <a:spcAft>
+                          <a:spcPts val="0"/>
+                        </a:spcAft>
+                      </a:pPr>
+                      <a:r>
+                        <a:rPr sz="1200" b="0">
+                          <a:solidFill>
+                            <a:srgbClr val="20262E"/>
+                          </a:solidFill>
+                          <a:latin typeface="맑은 고딕"/>
+                        </a:rPr>
+                        <a:t>배선 문제라면 다음 수집분도 똑같이 못 쓴다</a:t>
+                      </a:r>
+                    </a:p>
+                  </a:txBody>
+                  <a:tcPr marL="73152" marR="73152" marT="18288" marB="18288" anchor="ctr">
+                    <a:solidFill>
+                      <a:srgbClr val="FFFFFF"/>
+                    </a:solidFill>
+                  </a:tcPr>
+                </a:tc>
+              </a:tr>
+              <a:tr h="566928">
+                <a:tc>
+                  <a:txBody>
+                    <a:bodyPr wrap="square"/>
+                    <a:lstStyle/>
+                    <a:p>
+                      <a:pPr algn="l">
+                        <a:spcAft>
+                          <a:spcPts val="0"/>
+                        </a:spcAft>
+                      </a:pPr>
+                      <a:r>
+                        <a:rPr sz="1200" b="0">
+                          <a:solidFill>
+                            <a:srgbClr val="20262E"/>
+                          </a:solidFill>
+                          <a:latin typeface="맑은 고딕"/>
+                        </a:rPr>
+                        <a:t>손가락 1~13·17은 왜 제어되지 않나</a:t>
+                      </a:r>
+                    </a:p>
+                  </a:txBody>
+                  <a:tcPr marL="73152" marR="73152" marT="18288" marB="18288" anchor="ctr">
+                    <a:solidFill>
+                      <a:srgbClr val="F2F5F8"/>
+                    </a:solidFill>
+                  </a:tcPr>
+                </a:tc>
+                <a:tc>
+                  <a:txBody>
+                    <a:bodyPr wrap="square"/>
+                    <a:lstStyle/>
+                    <a:p>
+                      <a:pPr algn="l">
+                        <a:spcAft>
+                          <a:spcPts val="0"/>
+                        </a:spcAft>
+                      </a:pPr>
+                      <a:r>
+                        <a:rPr sz="1200" b="0">
+                          <a:solidFill>
+                            <a:srgbClr val="20262E"/>
+                          </a:solidFill>
+                          <a:latin typeface="맑은 고딕"/>
+                        </a:rPr>
+                        <a:t>2지 운용으로 보이지만 의도인지 토픽 누락인지 불명</a:t>
+                      </a:r>
+                    </a:p>
+                  </a:txBody>
+                  <a:tcPr marL="73152" marR="73152" marT="18288" marB="18288" anchor="ctr">
+                    <a:solidFill>
+                      <a:srgbClr val="F2F5F8"/>
+                    </a:solidFill>
+                  </a:tcPr>
+                </a:tc>
+                <a:tc>
+                  <a:txBody>
+                    <a:bodyPr wrap="square"/>
+                    <a:lstStyle/>
+                    <a:p>
+                      <a:pPr algn="l">
+                        <a:spcAft>
+                          <a:spcPts val="0"/>
+                        </a:spcAft>
+                      </a:pPr>
+                      <a:r>
+                        <a:rPr sz="1200" b="0">
+                          <a:solidFill>
+                            <a:srgbClr val="20262E"/>
+                          </a:solidFill>
+                          <a:latin typeface="맑은 고딕"/>
+                        </a:rPr>
+                        <a:t>5지로 바꾸면 26차원 체크포인트를 다시 학습해야 한다</a:t>
+                      </a:r>
+                    </a:p>
+                  </a:txBody>
+                  <a:tcPr marL="73152" marR="73152" marT="18288" marB="18288" anchor="ctr">
+                    <a:solidFill>
+                      <a:srgbClr val="F2F5F8"/>
                     </a:solidFill>
                   </a:tcPr>
                 </a:tc>
@@ -12974,7 +11854,477 @@
                 </a:solidFill>
                 <a:latin typeface="맑은 고딕"/>
               </a:rPr>
-              <a:t>          16</a:t>
+              <a:t>          15</a:t>
+            </a:r>
+          </a:p>
+        </p:txBody>
+      </p:sp>
+    </p:spTree>
+  </p:cSld>
+  <p:clrMapOvr>
+    <a:masterClrMapping/>
+  </p:clrMapOvr>
+</p:sld>
+</file>
+
+<file path=ppt/slides/slide17.xml><?xml version="1.0" encoding="utf-8"?>
+<p:sld xmlns:a="http://schemas.openxmlformats.org/drawingml/2006/main" xmlns:p="http://schemas.openxmlformats.org/presentationml/2006/main" xmlns:r="http://schemas.openxmlformats.org/officeDocument/2006/relationships">
+  <p:cSld>
+    <p:spTree>
+      <p:nvGrpSpPr>
+        <p:cNvPr id="1" name=""/>
+        <p:cNvGrpSpPr/>
+        <p:nvPr/>
+      </p:nvGrpSpPr>
+      <p:grpSpPr/>
+      <p:sp>
+        <p:nvSpPr>
+          <p:cNvPr id="2" name="TextBox 1"/>
+          <p:cNvSpPr txBox="1"/>
+          <p:nvPr/>
+        </p:nvSpPr>
+        <p:spPr>
+          <a:xfrm>
+            <a:off x="731520" y="2377440"/>
+            <a:ext cx="10698480" cy="1097280"/>
+          </a:xfrm>
+          <a:prstGeom prst="rect">
+            <a:avLst/>
+          </a:prstGeom>
+          <a:noFill/>
+        </p:spPr>
+        <p:txBody>
+          <a:bodyPr wrap="square">
+            <a:spAutoFit/>
+          </a:bodyPr>
+          <a:lstStyle/>
+          <a:p>
+            <a:r>
+              <a:rPr sz="4000" b="1">
+                <a:solidFill>
+                  <a:srgbClr val="1F3A5F"/>
+                </a:solidFill>
+              </a:rPr>
+              <a:t>업데이트 — 26.09.03</a:t>
+            </a:r>
+          </a:p>
+        </p:txBody>
+      </p:sp>
+      <p:sp>
+        <p:nvSpPr>
+          <p:cNvPr id="3" name="TextBox 2"/>
+          <p:cNvSpPr txBox="1"/>
+          <p:nvPr/>
+        </p:nvSpPr>
+        <p:spPr>
+          <a:xfrm>
+            <a:off x="731520" y="3474720"/>
+            <a:ext cx="10698480" cy="1463040"/>
+          </a:xfrm>
+          <a:prstGeom prst="rect">
+            <a:avLst/>
+          </a:prstGeom>
+          <a:noFill/>
+        </p:spPr>
+        <p:txBody>
+          <a:bodyPr wrap="square">
+            <a:spAutoFit/>
+          </a:bodyPr>
+          <a:lstStyle/>
+          <a:p>
+            <a:r>
+              <a:rPr sz="1600" b="0"/>
+              <a:t>이 뒤의 슬라이드는 26.08.27~09.03 실험 결과를 요약한다:</a:t>
+            </a:r>
+          </a:p>
+          <a:p>
+            <a:r>
+              <a:rPr sz="1600" b="0"/>
+              <a:t>① 1차 학습 결과와 checkpoint 선택  ② GR00T N1.7 비교(액션 표현 가설)  ③ subtask 언어 조건화 + 언어 민감도 프로브</a:t>
+            </a:r>
+          </a:p>
+          <a:p>
+            <a:r>
+              <a:rPr sz="1200" b="0">
+                <a:solidFill>
+                  <a:srgbClr val="666666"/>
+                </a:solidFill>
+              </a:rPr>
+              <a:t>상세 수치·플롯: eval_ffw_sh5_0826_holdout/ 트리, 비교 덱 RLDX1_vs_GR00T_N17_ffw_sh5_0826.pptx, 재현 문서 SUBTASK-TRAINING.md</a:t>
+            </a:r>
+          </a:p>
+        </p:txBody>
+      </p:sp>
+    </p:spTree>
+  </p:cSld>
+  <p:clrMapOvr>
+    <a:masterClrMapping/>
+  </p:clrMapOvr>
+</p:sld>
+</file>
+
+<file path=ppt/slides/slide18.xml><?xml version="1.0" encoding="utf-8"?>
+<p:sld xmlns:a="http://schemas.openxmlformats.org/drawingml/2006/main" xmlns:p="http://schemas.openxmlformats.org/presentationml/2006/main" xmlns:r="http://schemas.openxmlformats.org/officeDocument/2006/relationships">
+  <p:cSld>
+    <p:spTree>
+      <p:nvGrpSpPr>
+        <p:cNvPr id="1" name=""/>
+        <p:cNvGrpSpPr/>
+        <p:nvPr/>
+      </p:nvGrpSpPr>
+      <p:grpSpPr/>
+      <p:sp>
+        <p:nvSpPr>
+          <p:cNvPr id="2" name="TextBox 1"/>
+          <p:cNvSpPr txBox="1"/>
+          <p:nvPr/>
+        </p:nvSpPr>
+        <p:spPr>
+          <a:xfrm>
+            <a:off x="457200" y="228600"/>
+            <a:ext cx="11247120" cy="640080"/>
+          </a:xfrm>
+          <a:prstGeom prst="rect">
+            <a:avLst/>
+          </a:prstGeom>
+          <a:noFill/>
+        </p:spPr>
+        <p:txBody>
+          <a:bodyPr wrap="square">
+            <a:spAutoFit/>
+          </a:bodyPr>
+          <a:lstStyle/>
+          <a:p>
+            <a:r>
+              <a:rPr sz="2600" b="1">
+                <a:solidFill>
+                  <a:srgbClr val="1F3A5F"/>
+                </a:solidFill>
+              </a:rPr>
+              <a:t>① 1차 학습 결과 — checkpoint-10000 채택</a:t>
+            </a:r>
+          </a:p>
+        </p:txBody>
+      </p:sp>
+      <p:sp>
+        <p:nvSpPr>
+          <p:cNvPr id="3" name="TextBox 2"/>
+          <p:cNvSpPr txBox="1"/>
+          <p:nvPr/>
+        </p:nvSpPr>
+        <p:spPr>
+          <a:xfrm>
+            <a:off x="457200" y="777240"/>
+            <a:ext cx="11247120" cy="365760"/>
+          </a:xfrm>
+          <a:prstGeom prst="rect">
+            <a:avLst/>
+          </a:prstGeom>
+          <a:noFill/>
+        </p:spPr>
+        <p:txBody>
+          <a:bodyPr wrap="square">
+            <a:spAutoFit/>
+          </a:bodyPr>
+          <a:lstStyle/>
+          <a:p>
+            <a:r>
+              <a:rPr sz="1300" b="0">
+                <a:solidFill>
+                  <a:srgbClr val="666666"/>
+                </a:solidFill>
+              </a:rPr>
+              <a:t>batch 128 × 30K 완주, held-out 9 ep 전체 궤적 채점 (horizon 40)</a:t>
+            </a:r>
+          </a:p>
+        </p:txBody>
+      </p:sp>
+      <p:sp>
+        <p:nvSpPr>
+          <p:cNvPr id="4" name="TextBox 3"/>
+          <p:cNvSpPr txBox="1"/>
+          <p:nvPr/>
+        </p:nvSpPr>
+        <p:spPr>
+          <a:xfrm>
+            <a:off x="457200" y="1280160"/>
+            <a:ext cx="5760720" cy="4846320"/>
+          </a:xfrm>
+          <a:prstGeom prst="rect">
+            <a:avLst/>
+          </a:prstGeom>
+          <a:noFill/>
+        </p:spPr>
+        <p:txBody>
+          <a:bodyPr wrap="square">
+            <a:spAutoFit/>
+          </a:bodyPr>
+          <a:lstStyle/>
+          <a:p>
+            <a:r>
+              <a:rPr sz="1500" b="1">
+                <a:solidFill>
+                  <a:srgbClr val="1F3A5F"/>
+                </a:solidFill>
+              </a:rPr>
+              <a:t>결과</a:t>
+            </a:r>
+          </a:p>
+          <a:p>
+            <a:r>
+              <a:rPr sz="1300" b="0"/>
+              <a:t>• 최적: checkpoint-10000 — held-out MSE 0.0239 / MAE 0.0966</a:t>
+            </a:r>
+          </a:p>
+          <a:p>
+            <a:r>
+              <a:rPr sz="1300" b="0"/>
+              <a:t>• 20K·30K는 10K에 9/9 에피소드 전패 — 순수 과적합 (train loss는 4배 개선)</a:t>
+            </a:r>
+          </a:p>
+          <a:p>
+            <a:r>
+              <a:rPr sz="1300" b="0"/>
+              <a:t>• 81 에피소드에서는 ~1.3M 샘플이면 배울 것을 다 배운다 — 다음 레버는 스텝·용량이 아니라 데이터(§6.3 순서)</a:t>
+            </a:r>
+          </a:p>
+          <a:p>
+            <a:r>
+              <a:rPr sz="800" b="0"/>
+              <a:t/>
+            </a:r>
+          </a:p>
+          <a:p>
+            <a:r>
+              <a:rPr sz="1500" b="1">
+                <a:solidFill>
+                  <a:srgbClr val="1F3A5F"/>
+                </a:solidFill>
+              </a:rPr>
+              <a:t>평가 방법 교훈</a:t>
+            </a:r>
+          </a:p>
+          <a:p>
+            <a:r>
+              <a:rPr sz="1300" b="0"/>
+              <a:t>• 체크포인트 비교는 평균이 아니라 에피소드별 짝비교로 (같은 ckpt도 실행 간 ±15%)</a:t>
+            </a:r>
+          </a:p>
+          <a:p>
+            <a:r>
+              <a:rPr sz="1300" b="0"/>
+              <a:t>• 최초 채점이 --steps 128(앞 12.8초)로 되어 있던 것을 발견 — 전체 궤적 재채점으로 통일 (평균·결론은 유지: 0.0238→0.0239)</a:t>
+            </a:r>
+          </a:p>
+        </p:txBody>
+      </p:sp>
+      <p:pic>
+        <p:nvPicPr>
+          <p:cNvPr id="5" name="Picture 4" descr="train_loss_curves.png"/>
+          <p:cNvPicPr>
+            <a:picLocks noChangeAspect="1"/>
+          </p:cNvPicPr>
+          <p:nvPr/>
+        </p:nvPicPr>
+        <p:blipFill>
+          <a:blip r:embed="rId2"/>
+          <a:stretch>
+            <a:fillRect/>
+          </a:stretch>
+        </p:blipFill>
+        <p:spPr>
+          <a:xfrm>
+            <a:off x="6400800" y="1554480"/>
+            <a:ext cx="5486400" cy="1920240"/>
+          </a:xfrm>
+          <a:prstGeom prst="rect">
+            <a:avLst/>
+          </a:prstGeom>
+        </p:spPr>
+      </p:pic>
+    </p:spTree>
+  </p:cSld>
+  <p:clrMapOvr>
+    <a:masterClrMapping/>
+  </p:clrMapOvr>
+</p:sld>
+</file>
+
+<file path=ppt/slides/slide19.xml><?xml version="1.0" encoding="utf-8"?>
+<p:sld xmlns:a="http://schemas.openxmlformats.org/drawingml/2006/main" xmlns:p="http://schemas.openxmlformats.org/presentationml/2006/main" xmlns:r="http://schemas.openxmlformats.org/officeDocument/2006/relationships">
+  <p:cSld>
+    <p:spTree>
+      <p:nvGrpSpPr>
+        <p:cNvPr id="1" name=""/>
+        <p:cNvGrpSpPr/>
+        <p:nvPr/>
+      </p:nvGrpSpPr>
+      <p:grpSpPr/>
+      <p:sp>
+        <p:nvSpPr>
+          <p:cNvPr id="2" name="TextBox 1"/>
+          <p:cNvSpPr txBox="1"/>
+          <p:nvPr/>
+        </p:nvSpPr>
+        <p:spPr>
+          <a:xfrm>
+            <a:off x="457200" y="228600"/>
+            <a:ext cx="11247120" cy="640080"/>
+          </a:xfrm>
+          <a:prstGeom prst="rect">
+            <a:avLst/>
+          </a:prstGeom>
+          <a:noFill/>
+        </p:spPr>
+        <p:txBody>
+          <a:bodyPr wrap="square">
+            <a:spAutoFit/>
+          </a:bodyPr>
+          <a:lstStyle/>
+          <a:p>
+            <a:r>
+              <a:rPr sz="2600" b="1">
+                <a:solidFill>
+                  <a:srgbClr val="1F3A5F"/>
+                </a:solidFill>
+              </a:rPr>
+              <a:t>② GR00T N1.7 비교 — 격차의 정체는 액션 표현이었다</a:t>
+            </a:r>
+          </a:p>
+        </p:txBody>
+      </p:sp>
+      <p:sp>
+        <p:nvSpPr>
+          <p:cNvPr id="3" name="TextBox 2"/>
+          <p:cNvSpPr txBox="1"/>
+          <p:nvPr/>
+        </p:nvSpPr>
+        <p:spPr>
+          <a:xfrm>
+            <a:off x="457200" y="777240"/>
+            <a:ext cx="11247120" cy="365760"/>
+          </a:xfrm>
+          <a:prstGeom prst="rect">
+            <a:avLst/>
+          </a:prstGeom>
+          <a:noFill/>
+        </p:spPr>
+        <p:txBody>
+          <a:bodyPr wrap="square">
+            <a:spAutoFit/>
+          </a:bodyPr>
+          <a:lstStyle/>
+          <a:p>
+            <a:r>
+              <a:rPr sz="1300" b="0">
+                <a:solidFill>
+                  <a:srgbClr val="666666"/>
+                </a:solidFill>
+              </a:rPr>
+              <a:t>동일 데이터·분할·26차원·chunk 40, 4×B200</a:t>
+            </a:r>
+          </a:p>
+        </p:txBody>
+      </p:sp>
+      <p:pic>
+        <p:nvPicPr>
+          <p:cNvPr id="4" name="Picture 3" descr="ckpt_trend.png"/>
+          <p:cNvPicPr>
+            <a:picLocks noChangeAspect="1"/>
+          </p:cNvPicPr>
+          <p:nvPr/>
+        </p:nvPicPr>
+        <p:blipFill>
+          <a:blip r:embed="rId2"/>
+          <a:stretch>
+            <a:fillRect/>
+          </a:stretch>
+        </p:blipFill>
+        <p:spPr>
+          <a:xfrm>
+            <a:off x="457200" y="1371600"/>
+            <a:ext cx="5669280" cy="3023616"/>
+          </a:xfrm>
+          <a:prstGeom prst="rect">
+            <a:avLst/>
+          </a:prstGeom>
+        </p:spPr>
+      </p:pic>
+      <p:sp>
+        <p:nvSpPr>
+          <p:cNvPr id="5" name="TextBox 4"/>
+          <p:cNvSpPr txBox="1"/>
+          <p:nvPr/>
+        </p:nvSpPr>
+        <p:spPr>
+          <a:xfrm>
+            <a:off x="6400800" y="1371600"/>
+            <a:ext cx="5486400" cy="4846320"/>
+          </a:xfrm>
+          <a:prstGeom prst="rect">
+            <a:avLst/>
+          </a:prstGeom>
+          <a:noFill/>
+        </p:spPr>
+        <p:txBody>
+          <a:bodyPr wrap="square">
+            <a:spAutoFit/>
+          </a:bodyPr>
+          <a:lstStyle/>
+          <a:p>
+            <a:r>
+              <a:rPr sz="1500" b="1">
+                <a:solidFill>
+                  <a:srgbClr val="1F3A5F"/>
+                </a:solidFill>
+              </a:rPr>
+              <a:t>경과</a:t>
+            </a:r>
+          </a:p>
+          <a:p>
+            <a:r>
+              <a:rPr sz="1300" b="0"/>
+              <a:t>• GR00T-N1.7-3B ABSOLUTE로 학습 → RLDX-1에 9/9 열세 (+24%, 0.0297 vs 0.0239)</a:t>
+            </a:r>
+          </a:p>
+          <a:p>
+            <a:r>
+              <a:rPr sz="1300" b="0"/>
+              <a:t>• 팔만 RELATIVE(a−s_t)로 재파라미터화한 relarm 변형 → 격차 소멸: 0.0236, RLDX와 통계적 동률</a:t>
+            </a:r>
+          </a:p>
+          <a:p>
+            <a:r>
+              <a:rPr sz="800" b="0"/>
+              <a:t/>
+            </a:r>
+          </a:p>
+          <a:p>
+            <a:r>
+              <a:rPr sz="1500" b="1">
+                <a:solidFill>
+                  <a:srgbClr val="1F3A5F"/>
+                </a:solidFill>
+              </a:rPr>
+              <a:t>해석</a:t>
+            </a:r>
+          </a:p>
+          <a:p>
+            <a:r>
+              <a:rPr sz="1300" b="0"/>
+              <a:t>• N1.7 사전학습 코퍼스가 delta/relative 지배적 — 동결 DiT 트렁크에는 0-중심 타겟이 in-distribution</a:t>
+            </a:r>
+          </a:p>
+          <a:p>
+            <a:r>
+              <a:rPr sz="1300" b="0"/>
+              <a:t>• 용량(8B vs 3B)이 아니라 표현 정합이 지배 변수. relarm은 과적합 곡선도 평평(10k~50k 유지)</a:t>
+            </a:r>
+          </a:p>
+          <a:p>
+            <a:r>
+              <a:rPr sz="1300" b="0"/>
+              <a:t>• RLDX는 ABSOLUTE 유지가 맞음(A.2 결정 재확인)</a:t>
             </a:r>
           </a:p>
         </p:txBody>
@@ -13331,7 +12681,7 @@
                           </a:solidFill>
                           <a:latin typeface="맑은 고딕"/>
                         </a:rPr>
-                        <a:t>PT에 physics stream이 없고, 2지 파지라 신호가 36차원에만 희소</a:t>
+                        <a:t>90차원 중 11개만 살아있고, PT에 physics stream 자체가 없음</a:t>
                       </a:r>
                     </a:p>
                   </a:txBody>
@@ -13994,6 +13344,536 @@
                 <a:latin typeface="맑은 고딕"/>
               </a:rPr>
               <a:t>          1</a:t>
+            </a:r>
+          </a:p>
+        </p:txBody>
+      </p:sp>
+    </p:spTree>
+  </p:cSld>
+  <p:clrMapOvr>
+    <a:masterClrMapping/>
+  </p:clrMapOvr>
+</p:sld>
+</file>
+
+<file path=ppt/slides/slide20.xml><?xml version="1.0" encoding="utf-8"?>
+<p:sld xmlns:a="http://schemas.openxmlformats.org/drawingml/2006/main" xmlns:p="http://schemas.openxmlformats.org/presentationml/2006/main" xmlns:r="http://schemas.openxmlformats.org/officeDocument/2006/relationships">
+  <p:cSld>
+    <p:spTree>
+      <p:nvGrpSpPr>
+        <p:cNvPr id="1" name=""/>
+        <p:cNvGrpSpPr/>
+        <p:nvPr/>
+      </p:nvGrpSpPr>
+      <p:grpSpPr/>
+      <p:sp>
+        <p:nvSpPr>
+          <p:cNvPr id="2" name="TextBox 1"/>
+          <p:cNvSpPr txBox="1"/>
+          <p:nvPr/>
+        </p:nvSpPr>
+        <p:spPr>
+          <a:xfrm>
+            <a:off x="457200" y="228600"/>
+            <a:ext cx="11247120" cy="640080"/>
+          </a:xfrm>
+          <a:prstGeom prst="rect">
+            <a:avLst/>
+          </a:prstGeom>
+          <a:noFill/>
+        </p:spPr>
+        <p:txBody>
+          <a:bodyPr wrap="square">
+            <a:spAutoFit/>
+          </a:bodyPr>
+          <a:lstStyle/>
+          <a:p>
+            <a:r>
+              <a:rPr sz="2600" b="1">
+                <a:solidFill>
+                  <a:srgbClr val="1F3A5F"/>
+                </a:solidFill>
+              </a:rPr>
+              <a:t>③ subtask 재방문 — '이번엔 아니다'를 실험으로 확인했다</a:t>
+            </a:r>
+          </a:p>
+        </p:txBody>
+      </p:sp>
+      <p:sp>
+        <p:nvSpPr>
+          <p:cNvPr id="3" name="TextBox 2"/>
+          <p:cNvSpPr txBox="1"/>
+          <p:nvPr/>
+        </p:nvSpPr>
+        <p:spPr>
+          <a:xfrm>
+            <a:off x="457200" y="777240"/>
+            <a:ext cx="11247120" cy="365760"/>
+          </a:xfrm>
+          <a:prstGeom prst="rect">
+            <a:avLst/>
+          </a:prstGeom>
+          <a:noFill/>
+        </p:spPr>
+        <p:txBody>
+          <a:bodyPr wrap="square">
+            <a:spAutoFit/>
+          </a:bodyPr>
+          <a:lstStyle/>
+          <a:p>
+            <a:r>
+              <a:rPr sz="1300" b="0">
+                <a:solidFill>
+                  <a:srgbClr val="666666"/>
+                </a:solidFill>
+              </a:rPr>
+              <a:t>사람 라벨 3문장(bring/flip/push)을 프레임 단위 조건으로, train 코드 0줄 변경</a:t>
+            </a:r>
+          </a:p>
+        </p:txBody>
+      </p:sp>
+      <p:sp>
+        <p:nvSpPr>
+          <p:cNvPr id="4" name="TextBox 3"/>
+          <p:cNvSpPr txBox="1"/>
+          <p:nvPr/>
+        </p:nvSpPr>
+        <p:spPr>
+          <a:xfrm>
+            <a:off x="457200" y="1280160"/>
+            <a:ext cx="5760720" cy="4846320"/>
+          </a:xfrm>
+          <a:prstGeom prst="rect">
+            <a:avLst/>
+          </a:prstGeom>
+          <a:noFill/>
+        </p:spPr>
+        <p:txBody>
+          <a:bodyPr wrap="square">
+            <a:spAutoFit/>
+          </a:bodyPr>
+          <a:lstStyle/>
+          <a:p>
+            <a:r>
+              <a:rPr sz="1500" b="1">
+                <a:solidFill>
+                  <a:srgbClr val="1F3A5F"/>
+                </a:solidFill>
+              </a:rPr>
+              <a:t>한 것</a:t>
+            </a:r>
+          </a:p>
+          <a:p>
+            <a:r>
+              <a:rPr sz="1200" b="0"/>
+              <a:t>• 81 ep 전수 구간 라벨 → parquet task_index에 프레임 단위 스탬핑(데이터 변경만으로 조건화 전환)</a:t>
+            </a:r>
+          </a:p>
+          <a:p>
+            <a:r>
+              <a:rPr sz="1200" b="0"/>
+              <a:t>• 3개 run 전부 재학습: RLDX(ABS)·GR00T(ABS)·GR00T(relarm), 베이스라인과 동일 하이퍼파라미터</a:t>
+            </a:r>
+          </a:p>
+          <a:p>
+            <a:r>
+              <a:rPr sz="600" b="0"/>
+              <a:t/>
+            </a:r>
+          </a:p>
+          <a:p>
+            <a:r>
+              <a:rPr sz="1500" b="1">
+                <a:solidFill>
+                  <a:srgbClr val="1F3A5F"/>
+                </a:solidFill>
+              </a:rPr>
+              <a:t>결과 (oracle 시퀀서 holdout, 각 최적 ckpt)</a:t>
+            </a:r>
+          </a:p>
+          <a:p>
+            <a:r>
+              <a:rPr sz="1200" b="0"/>
+              <a:t>• RLDX: 0.0239 → 0.0241 (동률)</a:t>
+            </a:r>
+          </a:p>
+          <a:p>
+            <a:r>
+              <a:rPr sz="1200" b="0"/>
+              <a:t>• GR00T ABS: 0.0297 → 0.0308 (동률)</a:t>
+            </a:r>
+          </a:p>
+          <a:p>
+            <a:r>
+              <a:rPr sz="1200" b="0"/>
+              <a:t>• GR00T relarm: 0.0236 → 0.0239 (동률)</a:t>
+            </a:r>
+          </a:p>
+          <a:p>
+            <a:r>
+              <a:rPr sz="1200" b="0"/>
+              <a:t>• open-loop MSE 기준 이득 없음 — GT 재생에서는 phase를 틀릴 기회가 없어 예상된 결과</a:t>
+            </a:r>
+          </a:p>
+        </p:txBody>
+      </p:sp>
+      <p:pic>
+        <p:nvPicPr>
+          <p:cNvPr id="5" name="Picture 4" descr="subtask_pairs.png"/>
+          <p:cNvPicPr>
+            <a:picLocks noChangeAspect="1"/>
+          </p:cNvPicPr>
+          <p:nvPr/>
+        </p:nvPicPr>
+        <p:blipFill>
+          <a:blip r:embed="rId2"/>
+          <a:stretch>
+            <a:fillRect/>
+          </a:stretch>
+        </p:blipFill>
+        <p:spPr>
+          <a:xfrm>
+            <a:off x="6400800" y="1737360"/>
+            <a:ext cx="5577840" cy="1630446"/>
+          </a:xfrm>
+          <a:prstGeom prst="rect">
+            <a:avLst/>
+          </a:prstGeom>
+        </p:spPr>
+      </p:pic>
+    </p:spTree>
+  </p:cSld>
+  <p:clrMapOvr>
+    <a:masterClrMapping/>
+  </p:clrMapOvr>
+</p:sld>
+</file>
+
+<file path=ppt/slides/slide21.xml><?xml version="1.0" encoding="utf-8"?>
+<p:sld xmlns:a="http://schemas.openxmlformats.org/drawingml/2006/main" xmlns:p="http://schemas.openxmlformats.org/presentationml/2006/main" xmlns:r="http://schemas.openxmlformats.org/officeDocument/2006/relationships">
+  <p:cSld>
+    <p:spTree>
+      <p:nvGrpSpPr>
+        <p:cNvPr id="1" name=""/>
+        <p:cNvGrpSpPr/>
+        <p:nvPr/>
+      </p:nvGrpSpPr>
+      <p:grpSpPr/>
+      <p:sp>
+        <p:nvSpPr>
+          <p:cNvPr id="2" name="TextBox 1"/>
+          <p:cNvSpPr txBox="1"/>
+          <p:nvPr/>
+        </p:nvSpPr>
+        <p:spPr>
+          <a:xfrm>
+            <a:off x="457200" y="228600"/>
+            <a:ext cx="11247120" cy="640080"/>
+          </a:xfrm>
+          <a:prstGeom prst="rect">
+            <a:avLst/>
+          </a:prstGeom>
+          <a:noFill/>
+        </p:spPr>
+        <p:txBody>
+          <a:bodyPr wrap="square">
+            <a:spAutoFit/>
+          </a:bodyPr>
+          <a:lstStyle/>
+          <a:p>
+            <a:r>
+              <a:rPr sz="2600" b="1">
+                <a:solidFill>
+                  <a:srgbClr val="1F3A5F"/>
+                </a:solidFill>
+              </a:rPr>
+              <a:t>③-b 언어 민감도 프로브 — 판정</a:t>
+            </a:r>
+          </a:p>
+        </p:txBody>
+      </p:sp>
+      <p:sp>
+        <p:nvSpPr>
+          <p:cNvPr id="3" name="TextBox 2"/>
+          <p:cNvSpPr txBox="1"/>
+          <p:nvPr/>
+        </p:nvSpPr>
+        <p:spPr>
+          <a:xfrm>
+            <a:off x="457200" y="777240"/>
+            <a:ext cx="11247120" cy="365760"/>
+          </a:xfrm>
+          <a:prstGeom prst="rect">
+            <a:avLst/>
+          </a:prstGeom>
+          <a:noFill/>
+        </p:spPr>
+        <p:txBody>
+          <a:bodyPr wrap="square">
+            <a:spAutoFit/>
+          </a:bodyPr>
+          <a:lstStyle/>
+          <a:p>
+            <a:r>
+              <a:rPr sz="1300" b="0">
+                <a:solidFill>
+                  <a:srgbClr val="666666"/>
+                </a:solidFill>
+              </a:rPr>
+              <a:t>오답 라벨(순환 치환)·전체 문장을 넣었을 때 예측이 흔들리는가</a:t>
+            </a:r>
+          </a:p>
+        </p:txBody>
+      </p:sp>
+      <p:pic>
+        <p:nvPicPr>
+          <p:cNvPr id="4" name="Picture 3" descr="lang_probe.png"/>
+          <p:cNvPicPr>
+            <a:picLocks noChangeAspect="1"/>
+          </p:cNvPicPr>
+          <p:nvPr/>
+        </p:nvPicPr>
+        <p:blipFill>
+          <a:blip r:embed="rId2"/>
+          <a:stretch>
+            <a:fillRect/>
+          </a:stretch>
+        </p:blipFill>
+        <p:spPr>
+          <a:xfrm>
+            <a:off x="548640" y="1371600"/>
+            <a:ext cx="6217920" cy="2901696"/>
+          </a:xfrm>
+          <a:prstGeom prst="rect">
+            <a:avLst/>
+          </a:prstGeom>
+        </p:spPr>
+      </p:pic>
+      <p:sp>
+        <p:nvSpPr>
+          <p:cNvPr id="5" name="TextBox 4"/>
+          <p:cNvSpPr txBox="1"/>
+          <p:nvPr/>
+        </p:nvSpPr>
+        <p:spPr>
+          <a:xfrm>
+            <a:off x="7040880" y="1371600"/>
+            <a:ext cx="4846320" cy="5029200"/>
+          </a:xfrm>
+          <a:prstGeom prst="rect">
+            <a:avLst/>
+          </a:prstGeom>
+          <a:noFill/>
+        </p:spPr>
+        <p:txBody>
+          <a:bodyPr wrap="square">
+            <a:spAutoFit/>
+          </a:bodyPr>
+          <a:lstStyle/>
+          <a:p>
+            <a:r>
+              <a:rPr sz="1500" b="1">
+                <a:solidFill>
+                  <a:srgbClr val="1F3A5F"/>
+                </a:solidFill>
+              </a:rPr>
+              <a:t>결과</a:t>
+            </a:r>
+          </a:p>
+          <a:p>
+            <a:r>
+              <a:rPr sz="1300" b="0"/>
+              <a:t>• GR00T ABS: 오답 시 +11%, 9/9 악화 — 언어 사용함(약하게)</a:t>
+            </a:r>
+          </a:p>
+          <a:p>
+            <a:r>
+              <a:rPr sz="1300" b="0"/>
+              <a:t>• GR00T relarm: +7% — 더 약함</a:t>
+            </a:r>
+          </a:p>
+          <a:p>
+            <a:r>
+              <a:rPr sz="1300" b="0"/>
+              <a:t>• RLDX: ±0% — 언어 완전 무시</a:t>
+            </a:r>
+          </a:p>
+          <a:p>
+            <a:r>
+              <a:rPr sz="800" b="0"/>
+              <a:t/>
+            </a:r>
+          </a:p>
+          <a:p>
+            <a:r>
+              <a:rPr sz="1500" b="1">
+                <a:solidFill>
+                  <a:srgbClr val="1F3A5F"/>
+                </a:solidFill>
+              </a:rPr>
+              <a:t>원인과 결론</a:t>
+            </a:r>
+          </a:p>
+          <a:p>
+            <a:r>
+              <a:rPr sz="1300" b="0"/>
+              <a:t>• subtask 문장이 시각 상태와 완벽 상관 → 시각만으로 충분, 언어는 지름길로 우회됨 (RLDX는 4프레임 시각 문맥이라 특히)</a:t>
+            </a:r>
+          </a:p>
+          <a:p>
+            <a:r>
+              <a:rPr sz="1300" b="0"/>
+              <a:t>• 시퀀서로 정책을 제어하려면 '같은 장면·다른 명령' 데이터(교차 명령)로 상관을 깨야 함 — 그 전까지 배포는 whole-sentence로 충분</a:t>
+            </a:r>
+          </a:p>
+        </p:txBody>
+      </p:sp>
+    </p:spTree>
+  </p:cSld>
+  <p:clrMapOvr>
+    <a:masterClrMapping/>
+  </p:clrMapOvr>
+</p:sld>
+</file>
+
+<file path=ppt/slides/slide22.xml><?xml version="1.0" encoding="utf-8"?>
+<p:sld xmlns:a="http://schemas.openxmlformats.org/drawingml/2006/main" xmlns:p="http://schemas.openxmlformats.org/presentationml/2006/main" xmlns:r="http://schemas.openxmlformats.org/officeDocument/2006/relationships">
+  <p:cSld>
+    <p:spTree>
+      <p:nvGrpSpPr>
+        <p:cNvPr id="1" name=""/>
+        <p:cNvGrpSpPr/>
+        <p:nvPr/>
+      </p:nvGrpSpPr>
+      <p:grpSpPr/>
+      <p:sp>
+        <p:nvSpPr>
+          <p:cNvPr id="2" name="TextBox 1"/>
+          <p:cNvSpPr txBox="1"/>
+          <p:nvPr/>
+        </p:nvSpPr>
+        <p:spPr>
+          <a:xfrm>
+            <a:off x="457200" y="228600"/>
+            <a:ext cx="11247120" cy="640080"/>
+          </a:xfrm>
+          <a:prstGeom prst="rect">
+            <a:avLst/>
+          </a:prstGeom>
+          <a:noFill/>
+        </p:spPr>
+        <p:txBody>
+          <a:bodyPr wrap="square">
+            <a:spAutoFit/>
+          </a:bodyPr>
+          <a:lstStyle/>
+          <a:p>
+            <a:r>
+              <a:rPr sz="2600" b="1">
+                <a:solidFill>
+                  <a:srgbClr val="1F3A5F"/>
+                </a:solidFill>
+              </a:rPr>
+              <a:t>권고 (26.09.03 기준)</a:t>
+            </a:r>
+          </a:p>
+        </p:txBody>
+      </p:sp>
+      <p:sp>
+        <p:nvSpPr>
+          <p:cNvPr id="3" name="TextBox 2"/>
+          <p:cNvSpPr txBox="1"/>
+          <p:nvPr/>
+        </p:nvSpPr>
+        <p:spPr>
+          <a:xfrm>
+            <a:off x="457200" y="1188720"/>
+            <a:ext cx="11247120" cy="5212080"/>
+          </a:xfrm>
+          <a:prstGeom prst="rect">
+            <a:avLst/>
+          </a:prstGeom>
+          <a:noFill/>
+        </p:spPr>
+        <p:txBody>
+          <a:bodyPr wrap="square">
+            <a:spAutoFit/>
+          </a:bodyPr>
+          <a:lstStyle/>
+          <a:p>
+            <a:r>
+              <a:rPr sz="1600" b="1">
+                <a:solidFill>
+                  <a:srgbClr val="1F3A5F"/>
+                </a:solidFill>
+              </a:rPr>
+              <a:t>채택 체크포인트</a:t>
+            </a:r>
+          </a:p>
+          <a:p>
+            <a:r>
+              <a:rPr sz="1300" b="0"/>
+              <a:t>• RLDX-1: rldx1_ft_ffw_sh5_0826/checkpoint-10000 (MSE 0.0239) · GR00T: relarm/checkpoint-50000 (0.0236) — open-loop 동률, 실기 성공률과 추론 비용(3B가 경량)으로 최종 선택</a:t>
+            </a:r>
+          </a:p>
+          <a:p>
+            <a:r>
+              <a:rPr sz="800" b="0"/>
+              <a:t/>
+            </a:r>
+          </a:p>
+          <a:p>
+            <a:r>
+              <a:rPr sz="1600" b="1">
+                <a:solidFill>
+                  <a:srgbClr val="1F3A5F"/>
+                </a:solidFill>
+              </a:rPr>
+              <a:t>다음 레버 (우선순위)</a:t>
+            </a:r>
+          </a:p>
+          <a:p>
+            <a:r>
+              <a:rPr sz="1300" b="0"/>
+              <a:t>① 실기 rollout — 두 후보 비교 (chunk 40 예측, 앞 20 실행 2.0 s 후 재질의)</a:t>
+            </a:r>
+          </a:p>
+          <a:p>
+            <a:r>
+              <a:rPr sz="1300" b="0"/>
+              <a:t>② 데이터 수집 — 초기 송장 위치 분포. 6개 run 전부 같은 에피소드(0/6/8)에서 막힘 = 데이터가 상한이라는 가장 강한 증거</a:t>
+            </a:r>
+          </a:p>
+          <a:p>
+            <a:r>
+              <a:rPr sz="1300" b="0"/>
+              <a:t>③ subtask 후속 — 교차 명령 데이터로 언어-시각 상관을 깬 뒤에만 재시도 가치</a:t>
+            </a:r>
+          </a:p>
+          <a:p>
+            <a:r>
+              <a:rPr sz="800" b="0"/>
+              <a:t/>
+            </a:r>
+          </a:p>
+          <a:p>
+            <a:r>
+              <a:rPr sz="1600" b="1">
+                <a:solidFill>
+                  <a:srgbClr val="1F3A5F"/>
+                </a:solidFill>
+              </a:rPr>
+              <a:t>산출물</a:t>
+            </a:r>
+          </a:p>
+          <a:p>
+            <a:r>
+              <a:rPr sz="1200" b="0">
+                <a:solidFill>
+                  <a:srgbClr val="666666"/>
+                </a:solidFill>
+              </a:rPr>
+              <a:t>HF: learner1119/{rldx1_ft_ffw_sh5_0826, gr00t_n17_ffw_sh5_0826_b200, ..._relarm} + _subtask 3종 (전부 public, 가중치만) · 평가: /NHNHOME/doyoung/eval_ffw_sh5_0826_holdout/ · 문서: SUBTASK-TRAINING.md, RLDX-1-FFW-SH5.md §17.5</a:t>
             </a:r>
           </a:p>
         </p:txBody>
@@ -16374,7 +16254,7 @@
                 </a:solidFill>
                 <a:latin typeface="맑은 고딕"/>
               </a:rPr>
-              <a:t>조이스틱 프리셋 → 4·5번 손가락만 사용 (의도됨)</a:t>
+              <a:t>손은 사실상 2지 그리퍼로 운용 중</a:t>
             </a:r>
           </a:p>
           <a:p>
@@ -17059,7 +16939,7 @@
                 </a:solidFill>
                 <a:latin typeface="맑은 고딕"/>
               </a:rPr>
-              <a:t>설계가 그렇고, 모델도 아직 못 받는다</a:t>
+              <a:t>세 겹으로 막혀 있다</a:t>
             </a:r>
           </a:p>
         </p:txBody>
@@ -17354,7 +17234,7 @@
                           </a:solidFill>
                           <a:latin typeface="맑은 고딕"/>
                         </a:rPr>
-                        <a:t>운용</a:t>
+                        <a:t>하드웨어</a:t>
                       </a:r>
                     </a:p>
                   </a:txBody>
@@ -17381,7 +17261,7 @@
                           </a:solidFill>
                           <a:latin typeface="맑은 고딕"/>
                         </a:rPr>
-                        <a:t>2지 파지 설계 — 접촉이 4·5번 손가락에 집중</a:t>
+                        <a:t>양손 5개 센서 중 3개가 전 구간 무응답</a:t>
                       </a:r>
                     </a:p>
                   </a:txBody>
@@ -17540,7 +17420,7 @@
                 </a:solidFill>
                 <a:latin typeface="맑은 고딕"/>
               </a:rPr>
-              <a:t>접촉이 집중되는 곳 = 손가락 4·5번</a:t>
+              <a:t>살아있는 센서 = 손가락 4·5번뿐</a:t>
             </a:r>
           </a:p>
           <a:p>
@@ -17565,7 +17445,7 @@
                 </a:solidFill>
                 <a:latin typeface="맑은 고딕"/>
               </a:rPr>
-              <a:t>접촉 이벤트: 4·5번 2,580건 vs 1~3번 115건</a:t>
+              <a:t>왼손 센서 1·2·3 (dim 0–26): 전 구간 0</a:t>
             </a:r>
           </a:p>
           <a:p>
@@ -17590,7 +17470,7 @@
                 </a:solidFill>
                 <a:latin typeface="맑은 고딕"/>
               </a:rPr>
-              <a:t>1~3번도 스치면 최대 70~233까지 제대로 읽는다</a:t>
+              <a:t>오른손 센서 1·2·3 (dim 45–71): 전 구간 0</a:t>
             </a:r>
           </a:p>
           <a:p>
@@ -17615,7 +17495,7 @@
                 </a:solidFill>
                 <a:latin typeface="맑은 고딕"/>
               </a:rPr>
-              <a:t>→ 하드웨어 결함이 아니다. 쓰게 되면 36차원만 넣으면 됨</a:t>
+              <a:t>활성: 왼손 27–44, 오른손 72–89</a:t>
             </a:r>
           </a:p>
         </p:txBody>
@@ -17746,7 +17626,7 @@
                 </a:solidFill>
                 <a:latin typeface="맑은 고딕"/>
               </a:rPr>
-              <a:t>결정 ①과 같은 원인이다</a:t>
+              <a:t>결정 ①과 정확히 맞아떨어진다</a:t>
             </a:r>
           </a:p>
           <a:p>
@@ -17762,7 +17642,7 @@
                 </a:solidFill>
                 <a:latin typeface="맑은 고딕"/>
               </a:rPr>
-              <a:t>조이스틱 버튼 하나로 프리셋이 걸려</a:t>
+              <a:t>명령이 들어가는 손가락도 4·5번,</a:t>
             </a:r>
           </a:p>
           <a:p>
@@ -17778,7 +17658,7 @@
                 </a:solidFill>
                 <a:latin typeface="맑은 고딕"/>
               </a:rPr>
-              <a:t>4·5번 손가락(약지·새끼)만으로 상자를 파지한다.</a:t>
+              <a:t>tactile이 반응하는 센서도 4·5번.</a:t>
             </a:r>
           </a:p>
           <a:p>
@@ -17794,7 +17674,7 @@
                 </a:solidFill>
                 <a:latin typeface="맑은 고딕"/>
               </a:rPr>
-              <a:t>→ 명령도 접촉도 거기 몰리는 게 당연하다.</a:t>
+              <a:t>→ 이 데이터에서 손은 2지로 운용되고 있고</a:t>
             </a:r>
           </a:p>
           <a:p>
@@ -17810,7 +17690,7 @@
                 </a:solidFill>
                 <a:latin typeface="맑은 고딕"/>
               </a:rPr>
-              <a:t>   데이터를 다시 모아도 같은 모양이 나온다.</a:t>
+              <a:t>   1~3번은 제어도 센싱도 되지 않는다.</a:t>
             </a:r>
           </a:p>
         </p:txBody>
@@ -17973,7 +17853,7 @@
                 </a:solidFill>
                 <a:latin typeface="맑은 고딕"/>
               </a:rPr>
-              <a:t>상자 운반은 그 범주가 아니다. 나중에 쓰게 되면 파지에 실제로 쓰이는 36차원(4·5번 손가락)만 넣으면 된다.</a:t>
+              <a:t>상자 운반은 그 범주가 아니다. 다만 “센서 1~3번이 왜 무응답인가”는 지금 확인해 둬야 다음 수집이 쓸모 있다.</a:t>
             </a:r>
           </a:p>
         </p:txBody>

</xml_diff>